<commit_message>
Corrected empirical bootstrap values heterochrony analysis to take into account finite number of bootstrap resamples
</commit_message>
<xml_diff>
--- a/output/figures/Fig1.pptx
+++ b/output/figures/Fig1.pptx
@@ -12614,7 +12614,7 @@
           </p:nvSpPr>
           <p:spPr>
             <a:xfrm>
-              <a:off x="7319991" y="6140090"/>
+              <a:off x="7325190" y="6140090"/>
               <a:ext cx="59480" cy="59480"/>
             </a:xfrm>
             <a:prstGeom prst="ellipse">
@@ -12649,7 +12649,7 @@
           </p:nvSpPr>
           <p:spPr>
             <a:xfrm>
-              <a:off x="7280721" y="6021385"/>
+              <a:off x="7285456" y="6021385"/>
               <a:ext cx="66579" cy="66579"/>
             </a:xfrm>
             <a:prstGeom prst="ellipse">
@@ -12684,7 +12684,77 @@
           </p:nvSpPr>
           <p:spPr>
             <a:xfrm>
-              <a:off x="7224670" y="5909781"/>
+              <a:off x="7242761" y="5906231"/>
+              <a:ext cx="66579" cy="66579"/>
+            </a:xfrm>
+            <a:prstGeom prst="ellipse">
+              <a:avLst/>
+            </a:prstGeom>
+            <a:solidFill>
+              <a:srgbClr val="164BCE">
+                <a:alpha val="100000"/>
+              </a:srgbClr>
+            </a:solidFill>
+            <a:ln w="9818" cap="rnd">
+              <a:solidFill>
+                <a:srgbClr val="164BCE">
+                  <a:alpha val="100000"/>
+                </a:srgbClr>
+              </a:solidFill>
+              <a:prstDash val="solid"/>
+              <a:round/>
+            </a:ln>
+          </p:spPr>
+          <p:txBody>
+            <a:bodyPr/>
+            <a:lstStyle/>
+            <a:p/>
+          </p:txBody>
+        </p:sp>
+        <p:sp>
+          <p:nvSpPr>
+            <p:cNvPr id="280" name="pt65"/>
+            <p:cNvSpPr/>
+            <p:nvPr/>
+          </p:nvSpPr>
+          <p:spPr>
+            <a:xfrm>
+              <a:off x="7242761" y="5791076"/>
+              <a:ext cx="66579" cy="66579"/>
+            </a:xfrm>
+            <a:prstGeom prst="ellipse">
+              <a:avLst/>
+            </a:prstGeom>
+            <a:solidFill>
+              <a:srgbClr val="164BCE">
+                <a:alpha val="100000"/>
+              </a:srgbClr>
+            </a:solidFill>
+            <a:ln w="9818" cap="rnd">
+              <a:solidFill>
+                <a:srgbClr val="164BCE">
+                  <a:alpha val="100000"/>
+                </a:srgbClr>
+              </a:solidFill>
+              <a:prstDash val="solid"/>
+              <a:round/>
+            </a:ln>
+          </p:spPr>
+          <p:txBody>
+            <a:bodyPr/>
+            <a:lstStyle/>
+            <a:p/>
+          </p:txBody>
+        </p:sp>
+        <p:sp>
+          <p:nvSpPr>
+            <p:cNvPr id="281" name="pt66"/>
+            <p:cNvSpPr/>
+            <p:nvPr/>
+          </p:nvSpPr>
+          <p:spPr>
+            <a:xfrm>
+              <a:off x="7230282" y="5679472"/>
               <a:ext cx="59480" cy="59480"/>
             </a:xfrm>
             <a:prstGeom prst="ellipse">
@@ -12713,13 +12783,13 @@
         </p:sp>
         <p:sp>
           <p:nvSpPr>
-            <p:cNvPr id="280" name="pt65"/>
-            <p:cNvSpPr/>
-            <p:nvPr/>
-          </p:nvSpPr>
-          <p:spPr>
-            <a:xfrm>
-              <a:off x="7208374" y="5782204"/>
+            <p:cNvPr id="282" name="pt67"/>
+            <p:cNvSpPr/>
+            <p:nvPr/>
+          </p:nvSpPr>
+          <p:spPr>
+            <a:xfrm>
+              <a:off x="7216558" y="5551895"/>
               <a:ext cx="84324" cy="84324"/>
             </a:xfrm>
             <a:prstGeom prst="ellipse">
@@ -12748,13 +12818,13 @@
         </p:sp>
         <p:sp>
           <p:nvSpPr>
-            <p:cNvPr id="281" name="pt66"/>
-            <p:cNvSpPr/>
-            <p:nvPr/>
-          </p:nvSpPr>
-          <p:spPr>
-            <a:xfrm>
-              <a:off x="7207872" y="5667049"/>
+            <p:cNvPr id="283" name="pt68"/>
+            <p:cNvSpPr/>
+            <p:nvPr/>
+          </p:nvSpPr>
+          <p:spPr>
+            <a:xfrm>
+              <a:off x="7215228" y="5436740"/>
               <a:ext cx="84324" cy="84324"/>
             </a:xfrm>
             <a:prstGeom prst="ellipse">
@@ -12783,14 +12853,49 @@
         </p:sp>
         <p:sp>
           <p:nvSpPr>
-            <p:cNvPr id="282" name="pt67"/>
-            <p:cNvSpPr/>
-            <p:nvPr/>
-          </p:nvSpPr>
-          <p:spPr>
-            <a:xfrm>
-              <a:off x="7202395" y="5547177"/>
-              <a:ext cx="93760" cy="93760"/>
+            <p:cNvPr id="284" name="pt69"/>
+            <p:cNvSpPr/>
+            <p:nvPr/>
+          </p:nvSpPr>
+          <p:spPr>
+            <a:xfrm>
+              <a:off x="7201940" y="5308297"/>
+              <a:ext cx="110901" cy="110901"/>
+            </a:xfrm>
+            <a:prstGeom prst="ellipse">
+              <a:avLst/>
+            </a:prstGeom>
+            <a:solidFill>
+              <a:srgbClr val="159230">
+                <a:alpha val="100000"/>
+              </a:srgbClr>
+            </a:solidFill>
+            <a:ln w="9818" cap="rnd">
+              <a:solidFill>
+                <a:srgbClr val="159230">
+                  <a:alpha val="100000"/>
+                </a:srgbClr>
+              </a:solidFill>
+              <a:prstDash val="solid"/>
+              <a:round/>
+            </a:ln>
+          </p:spPr>
+          <p:txBody>
+            <a:bodyPr/>
+            <a:lstStyle/>
+            <a:p/>
+          </p:txBody>
+        </p:sp>
+        <p:sp>
+          <p:nvSpPr>
+            <p:cNvPr id="285" name="pt70"/>
+            <p:cNvSpPr/>
+            <p:nvPr/>
+          </p:nvSpPr>
+          <p:spPr>
+            <a:xfrm>
+              <a:off x="7230357" y="5227423"/>
+              <a:ext cx="42339" cy="42339"/>
             </a:xfrm>
             <a:prstGeom prst="ellipse">
               <a:avLst/>
@@ -12818,14 +12923,14 @@
         </p:sp>
         <p:sp>
           <p:nvSpPr>
-            <p:cNvPr id="283" name="pt68"/>
-            <p:cNvSpPr/>
-            <p:nvPr/>
-          </p:nvSpPr>
-          <p:spPr>
-            <a:xfrm>
-              <a:off x="7193313" y="5423452"/>
-              <a:ext cx="110901" cy="110901"/>
+            <p:cNvPr id="286" name="pt71"/>
+            <p:cNvSpPr/>
+            <p:nvPr/>
+          </p:nvSpPr>
+          <p:spPr>
+            <a:xfrm>
+              <a:off x="7210395" y="5097425"/>
+              <a:ext cx="72027" cy="72027"/>
             </a:xfrm>
             <a:prstGeom prst="ellipse">
               <a:avLst/>
@@ -12853,14 +12958,49 @@
         </p:sp>
         <p:sp>
           <p:nvSpPr>
-            <p:cNvPr id="284" name="pt69"/>
-            <p:cNvSpPr/>
-            <p:nvPr/>
-          </p:nvSpPr>
-          <p:spPr>
-            <a:xfrm>
-              <a:off x="7226033" y="5342578"/>
-              <a:ext cx="42339" cy="42339"/>
+            <p:cNvPr id="287" name="pt72"/>
+            <p:cNvSpPr/>
+            <p:nvPr/>
+          </p:nvSpPr>
+          <p:spPr>
+            <a:xfrm>
+              <a:off x="7210395" y="4982270"/>
+              <a:ext cx="72027" cy="72027"/>
+            </a:xfrm>
+            <a:prstGeom prst="ellipse">
+              <a:avLst/>
+            </a:prstGeom>
+            <a:solidFill>
+              <a:srgbClr val="164BCE">
+                <a:alpha val="100000"/>
+              </a:srgbClr>
+            </a:solidFill>
+            <a:ln w="9818" cap="rnd">
+              <a:solidFill>
+                <a:srgbClr val="164BCE">
+                  <a:alpha val="100000"/>
+                </a:srgbClr>
+              </a:solidFill>
+              <a:prstDash val="solid"/>
+              <a:round/>
+            </a:ln>
+          </p:spPr>
+          <p:txBody>
+            <a:bodyPr/>
+            <a:lstStyle/>
+            <a:p/>
+          </p:txBody>
+        </p:sp>
+        <p:sp>
+          <p:nvSpPr>
+            <p:cNvPr id="288" name="pt73"/>
+            <p:cNvSpPr/>
+            <p:nvPr/>
+          </p:nvSpPr>
+          <p:spPr>
+            <a:xfrm>
+              <a:off x="7212820" y="4873390"/>
+              <a:ext cx="59480" cy="59480"/>
             </a:xfrm>
             <a:prstGeom prst="ellipse">
               <a:avLst/>
@@ -12888,14 +13028,154 @@
         </p:sp>
         <p:sp>
           <p:nvSpPr>
-            <p:cNvPr id="285" name="pt70"/>
-            <p:cNvSpPr/>
-            <p:nvPr/>
-          </p:nvSpPr>
-          <p:spPr>
-            <a:xfrm>
-              <a:off x="7203348" y="5212579"/>
-              <a:ext cx="72027" cy="72027"/>
+            <p:cNvPr id="289" name="pt74"/>
+            <p:cNvSpPr/>
+            <p:nvPr/>
+          </p:nvSpPr>
+          <p:spPr>
+            <a:xfrm>
+              <a:off x="7212820" y="4758235"/>
+              <a:ext cx="59480" cy="59480"/>
+            </a:xfrm>
+            <a:prstGeom prst="ellipse">
+              <a:avLst/>
+            </a:prstGeom>
+            <a:solidFill>
+              <a:srgbClr val="E02020">
+                <a:alpha val="100000"/>
+              </a:srgbClr>
+            </a:solidFill>
+            <a:ln w="9818" cap="rnd">
+              <a:solidFill>
+                <a:srgbClr val="E02020">
+                  <a:alpha val="100000"/>
+                </a:srgbClr>
+              </a:solidFill>
+              <a:prstDash val="solid"/>
+              <a:round/>
+            </a:ln>
+          </p:spPr>
+          <p:txBody>
+            <a:bodyPr/>
+            <a:lstStyle/>
+            <a:p/>
+          </p:txBody>
+        </p:sp>
+        <p:sp>
+          <p:nvSpPr>
+            <p:cNvPr id="290" name="pt75"/>
+            <p:cNvSpPr/>
+            <p:nvPr/>
+          </p:nvSpPr>
+          <p:spPr>
+            <a:xfrm>
+              <a:off x="7196581" y="4627411"/>
+              <a:ext cx="90819" cy="90819"/>
+            </a:xfrm>
+            <a:prstGeom prst="ellipse">
+              <a:avLst/>
+            </a:prstGeom>
+            <a:solidFill>
+              <a:srgbClr val="164BCE">
+                <a:alpha val="100000"/>
+              </a:srgbClr>
+            </a:solidFill>
+            <a:ln w="9818" cap="rnd">
+              <a:solidFill>
+                <a:srgbClr val="164BCE">
+                  <a:alpha val="100000"/>
+                </a:srgbClr>
+              </a:solidFill>
+              <a:prstDash val="solid"/>
+              <a:round/>
+            </a:ln>
+          </p:spPr>
+          <p:txBody>
+            <a:bodyPr/>
+            <a:lstStyle/>
+            <a:p/>
+          </p:txBody>
+        </p:sp>
+        <p:sp>
+          <p:nvSpPr>
+            <p:cNvPr id="291" name="pt76"/>
+            <p:cNvSpPr/>
+            <p:nvPr/>
+          </p:nvSpPr>
+          <p:spPr>
+            <a:xfrm>
+              <a:off x="7170596" y="4494511"/>
+              <a:ext cx="126309" cy="126309"/>
+            </a:xfrm>
+            <a:prstGeom prst="ellipse">
+              <a:avLst/>
+            </a:prstGeom>
+            <a:solidFill>
+              <a:srgbClr val="164BCE">
+                <a:alpha val="100000"/>
+              </a:srgbClr>
+            </a:solidFill>
+            <a:ln w="9818" cap="rnd">
+              <a:solidFill>
+                <a:srgbClr val="164BCE">
+                  <a:alpha val="100000"/>
+                </a:srgbClr>
+              </a:solidFill>
+              <a:prstDash val="solid"/>
+              <a:round/>
+            </a:ln>
+          </p:spPr>
+          <p:txBody>
+            <a:bodyPr/>
+            <a:lstStyle/>
+            <a:p/>
+          </p:txBody>
+        </p:sp>
+        <p:sp>
+          <p:nvSpPr>
+            <p:cNvPr id="292" name="pt77"/>
+            <p:cNvSpPr/>
+            <p:nvPr/>
+          </p:nvSpPr>
+          <p:spPr>
+            <a:xfrm>
+              <a:off x="7176573" y="4404201"/>
+              <a:ext cx="76620" cy="76620"/>
+            </a:xfrm>
+            <a:prstGeom prst="ellipse">
+              <a:avLst/>
+            </a:prstGeom>
+            <a:solidFill>
+              <a:srgbClr val="164BCE">
+                <a:alpha val="100000"/>
+              </a:srgbClr>
+            </a:solidFill>
+            <a:ln w="9818" cap="rnd">
+              <a:solidFill>
+                <a:srgbClr val="164BCE">
+                  <a:alpha val="100000"/>
+                </a:srgbClr>
+              </a:solidFill>
+              <a:prstDash val="solid"/>
+              <a:round/>
+            </a:ln>
+          </p:spPr>
+          <p:txBody>
+            <a:bodyPr/>
+            <a:lstStyle/>
+            <a:p/>
+          </p:txBody>
+        </p:sp>
+        <p:sp>
+          <p:nvSpPr>
+            <p:cNvPr id="293" name="pt78"/>
+            <p:cNvSpPr/>
+            <p:nvPr/>
+          </p:nvSpPr>
+          <p:spPr>
+            <a:xfrm>
+              <a:off x="7158028" y="4276499"/>
+              <a:ext cx="101715" cy="101715"/>
             </a:xfrm>
             <a:prstGeom prst="ellipse">
               <a:avLst/>
@@ -12923,13 +13203,13 @@
         </p:sp>
         <p:sp>
           <p:nvSpPr>
-            <p:cNvPr id="286" name="pt71"/>
-            <p:cNvSpPr/>
-            <p:nvPr/>
-          </p:nvSpPr>
-          <p:spPr>
-            <a:xfrm>
-              <a:off x="7203348" y="5097425"/>
+            <p:cNvPr id="294" name="pt79"/>
+            <p:cNvSpPr/>
+            <p:nvPr/>
+          </p:nvSpPr>
+          <p:spPr>
+            <a:xfrm>
+              <a:off x="7169898" y="4176188"/>
               <a:ext cx="72027" cy="72027"/>
             </a:xfrm>
             <a:prstGeom prst="ellipse">
@@ -12958,14 +13238,14 @@
         </p:sp>
         <p:sp>
           <p:nvSpPr>
-            <p:cNvPr id="287" name="pt72"/>
-            <p:cNvSpPr/>
-            <p:nvPr/>
-          </p:nvSpPr>
-          <p:spPr>
-            <a:xfrm>
-              <a:off x="7207190" y="4988544"/>
-              <a:ext cx="59480" cy="59480"/>
+            <p:cNvPr id="295" name="pt80"/>
+            <p:cNvSpPr/>
+            <p:nvPr/>
+          </p:nvSpPr>
+          <p:spPr>
+            <a:xfrm>
+              <a:off x="7157641" y="4048777"/>
+              <a:ext cx="96542" cy="96542"/>
             </a:xfrm>
             <a:prstGeom prst="ellipse">
               <a:avLst/>
@@ -12993,49 +13273,14 @@
         </p:sp>
         <p:sp>
           <p:nvSpPr>
-            <p:cNvPr id="288" name="pt73"/>
-            <p:cNvSpPr/>
-            <p:nvPr/>
-          </p:nvSpPr>
-          <p:spPr>
-            <a:xfrm>
-              <a:off x="7207190" y="4873390"/>
-              <a:ext cx="59480" cy="59480"/>
-            </a:xfrm>
-            <a:prstGeom prst="ellipse">
-              <a:avLst/>
-            </a:prstGeom>
-            <a:solidFill>
-              <a:srgbClr val="E02020">
-                <a:alpha val="100000"/>
-              </a:srgbClr>
-            </a:solidFill>
-            <a:ln w="9818" cap="rnd">
-              <a:solidFill>
-                <a:srgbClr val="E02020">
-                  <a:alpha val="100000"/>
-                </a:srgbClr>
-              </a:solidFill>
-              <a:prstDash val="solid"/>
-              <a:round/>
-            </a:ln>
-          </p:spPr>
-          <p:txBody>
-            <a:bodyPr/>
-            <a:lstStyle/>
-            <a:p/>
-          </p:txBody>
-        </p:sp>
-        <p:sp>
-          <p:nvSpPr>
-            <p:cNvPr id="289" name="pt74"/>
-            <p:cNvSpPr/>
-            <p:nvPr/>
-          </p:nvSpPr>
-          <p:spPr>
-            <a:xfrm>
-              <a:off x="7207190" y="4758235"/>
-              <a:ext cx="59480" cy="59480"/>
+            <p:cNvPr id="296" name="pt81"/>
+            <p:cNvSpPr/>
+            <p:nvPr/>
+          </p:nvSpPr>
+          <p:spPr>
+            <a:xfrm>
+              <a:off x="7166061" y="3943583"/>
+              <a:ext cx="76620" cy="76620"/>
             </a:xfrm>
             <a:prstGeom prst="ellipse">
               <a:avLst/>
@@ -13063,14 +13308,84 @@
         </p:sp>
         <p:sp>
           <p:nvSpPr>
-            <p:cNvPr id="290" name="pt75"/>
-            <p:cNvSpPr/>
-            <p:nvPr/>
-          </p:nvSpPr>
-          <p:spPr>
-            <a:xfrm>
-              <a:off x="7191520" y="4627411"/>
-              <a:ext cx="90819" cy="90819"/>
+            <p:cNvPr id="297" name="pt82"/>
+            <p:cNvSpPr/>
+            <p:nvPr/>
+          </p:nvSpPr>
+          <p:spPr>
+            <a:xfrm>
+              <a:off x="7167881" y="3833449"/>
+              <a:ext cx="66579" cy="66579"/>
+            </a:xfrm>
+            <a:prstGeom prst="ellipse">
+              <a:avLst/>
+            </a:prstGeom>
+            <a:solidFill>
+              <a:srgbClr val="111111">
+                <a:alpha val="100000"/>
+              </a:srgbClr>
+            </a:solidFill>
+            <a:ln w="9818" cap="rnd">
+              <a:solidFill>
+                <a:srgbClr val="111111">
+                  <a:alpha val="100000"/>
+                </a:srgbClr>
+              </a:solidFill>
+              <a:prstDash val="solid"/>
+              <a:round/>
+            </a:ln>
+          </p:spPr>
+          <p:txBody>
+            <a:bodyPr/>
+            <a:lstStyle/>
+            <a:p/>
+          </p:txBody>
+        </p:sp>
+        <p:sp>
+          <p:nvSpPr>
+            <p:cNvPr id="298" name="pt83"/>
+            <p:cNvSpPr/>
+            <p:nvPr/>
+          </p:nvSpPr>
+          <p:spPr>
+            <a:xfrm>
+              <a:off x="7158609" y="3711251"/>
+              <a:ext cx="80666" cy="80666"/>
+            </a:xfrm>
+            <a:prstGeom prst="ellipse">
+              <a:avLst/>
+            </a:prstGeom>
+            <a:solidFill>
+              <a:srgbClr val="111111">
+                <a:alpha val="100000"/>
+              </a:srgbClr>
+            </a:solidFill>
+            <a:ln w="9818" cap="rnd">
+              <a:solidFill>
+                <a:srgbClr val="111111">
+                  <a:alpha val="100000"/>
+                </a:srgbClr>
+              </a:solidFill>
+              <a:prstDash val="solid"/>
+              <a:round/>
+            </a:ln>
+          </p:spPr>
+          <p:txBody>
+            <a:bodyPr/>
+            <a:lstStyle/>
+            <a:p/>
+          </p:txBody>
+        </p:sp>
+        <p:sp>
+          <p:nvSpPr>
+            <p:cNvPr id="299" name="pt84"/>
+            <p:cNvSpPr/>
+            <p:nvPr/>
+          </p:nvSpPr>
+          <p:spPr>
+            <a:xfrm>
+              <a:off x="7125526" y="3582067"/>
+              <a:ext cx="108723" cy="108723"/>
             </a:xfrm>
             <a:prstGeom prst="ellipse">
               <a:avLst/>
@@ -13098,14 +13413,14 @@
         </p:sp>
         <p:sp>
           <p:nvSpPr>
-            <p:cNvPr id="291" name="pt76"/>
-            <p:cNvSpPr/>
-            <p:nvPr/>
-          </p:nvSpPr>
-          <p:spPr>
-            <a:xfrm>
-              <a:off x="7164568" y="4491147"/>
-              <a:ext cx="133037" cy="133037"/>
+            <p:cNvPr id="300" name="pt85"/>
+            <p:cNvSpPr/>
+            <p:nvPr/>
+          </p:nvSpPr>
+          <p:spPr>
+            <a:xfrm>
+              <a:off x="7123160" y="3485261"/>
+              <a:ext cx="72027" cy="72027"/>
             </a:xfrm>
             <a:prstGeom prst="ellipse">
               <a:avLst/>
@@ -13133,14 +13448,14 @@
         </p:sp>
         <p:sp>
           <p:nvSpPr>
-            <p:cNvPr id="292" name="pt77"/>
-            <p:cNvSpPr/>
-            <p:nvPr/>
-          </p:nvSpPr>
-          <p:spPr>
-            <a:xfrm>
-              <a:off x="7177084" y="4406498"/>
-              <a:ext cx="72027" cy="72027"/>
+            <p:cNvPr id="301" name="pt86"/>
+            <p:cNvSpPr/>
+            <p:nvPr/>
+          </p:nvSpPr>
+          <p:spPr>
+            <a:xfrm>
+              <a:off x="7110448" y="3367810"/>
+              <a:ext cx="76620" cy="76620"/>
             </a:xfrm>
             <a:prstGeom prst="ellipse">
               <a:avLst/>
@@ -13168,14 +13483,14 @@
         </p:sp>
         <p:sp>
           <p:nvSpPr>
-            <p:cNvPr id="293" name="pt78"/>
-            <p:cNvSpPr/>
-            <p:nvPr/>
-          </p:nvSpPr>
-          <p:spPr>
-            <a:xfrm>
-              <a:off x="7172482" y="4289047"/>
-              <a:ext cx="76620" cy="76620"/>
+            <p:cNvPr id="302" name="pt87"/>
+            <p:cNvSpPr/>
+            <p:nvPr/>
+          </p:nvSpPr>
+          <p:spPr>
+            <a:xfrm>
+              <a:off x="7108425" y="3250632"/>
+              <a:ext cx="80666" cy="80666"/>
             </a:xfrm>
             <a:prstGeom prst="ellipse">
               <a:avLst/>
@@ -13203,14 +13518,294 @@
         </p:sp>
         <p:sp>
           <p:nvSpPr>
-            <p:cNvPr id="294" name="pt79"/>
-            <p:cNvSpPr/>
-            <p:nvPr/>
-          </p:nvSpPr>
-          <p:spPr>
-            <a:xfrm>
-              <a:off x="7148085" y="4161344"/>
-              <a:ext cx="101715" cy="101715"/>
+            <p:cNvPr id="303" name="pt88"/>
+            <p:cNvSpPr/>
+            <p:nvPr/>
+          </p:nvSpPr>
+          <p:spPr>
+            <a:xfrm>
+              <a:off x="7111575" y="3142521"/>
+              <a:ext cx="66579" cy="66579"/>
+            </a:xfrm>
+            <a:prstGeom prst="ellipse">
+              <a:avLst/>
+            </a:prstGeom>
+            <a:solidFill>
+              <a:srgbClr val="164BCE">
+                <a:alpha val="100000"/>
+              </a:srgbClr>
+            </a:solidFill>
+            <a:ln w="9818" cap="rnd">
+              <a:solidFill>
+                <a:srgbClr val="164BCE">
+                  <a:alpha val="100000"/>
+                </a:srgbClr>
+              </a:solidFill>
+              <a:prstDash val="solid"/>
+              <a:round/>
+            </a:ln>
+          </p:spPr>
+          <p:txBody>
+            <a:bodyPr/>
+            <a:lstStyle/>
+            <a:p/>
+          </p:txBody>
+        </p:sp>
+        <p:sp>
+          <p:nvSpPr>
+            <p:cNvPr id="304" name="pt89"/>
+            <p:cNvSpPr/>
+            <p:nvPr/>
+          </p:nvSpPr>
+          <p:spPr>
+            <a:xfrm>
+              <a:off x="7081240" y="2998386"/>
+              <a:ext cx="124541" cy="124541"/>
+            </a:xfrm>
+            <a:prstGeom prst="ellipse">
+              <a:avLst/>
+            </a:prstGeom>
+            <a:solidFill>
+              <a:srgbClr val="164BCE">
+                <a:alpha val="100000"/>
+              </a:srgbClr>
+            </a:solidFill>
+            <a:ln w="9818" cap="rnd">
+              <a:solidFill>
+                <a:srgbClr val="164BCE">
+                  <a:alpha val="100000"/>
+                </a:srgbClr>
+              </a:solidFill>
+              <a:prstDash val="solid"/>
+              <a:round/>
+            </a:ln>
+          </p:spPr>
+          <p:txBody>
+            <a:bodyPr/>
+            <a:lstStyle/>
+            <a:p/>
+          </p:txBody>
+        </p:sp>
+        <p:sp>
+          <p:nvSpPr>
+            <p:cNvPr id="305" name="pt90"/>
+            <p:cNvSpPr/>
+            <p:nvPr/>
+          </p:nvSpPr>
+          <p:spPr>
+            <a:xfrm>
+              <a:off x="7059409" y="2875100"/>
+              <a:ext cx="140803" cy="140803"/>
+            </a:xfrm>
+            <a:prstGeom prst="ellipse">
+              <a:avLst/>
+            </a:prstGeom>
+            <a:solidFill>
+              <a:srgbClr val="164BCE">
+                <a:alpha val="100000"/>
+              </a:srgbClr>
+            </a:solidFill>
+            <a:ln w="9818" cap="rnd">
+              <a:solidFill>
+                <a:srgbClr val="164BCE">
+                  <a:alpha val="100000"/>
+                </a:srgbClr>
+              </a:solidFill>
+              <a:prstDash val="solid"/>
+              <a:round/>
+            </a:ln>
+          </p:spPr>
+          <p:txBody>
+            <a:bodyPr/>
+            <a:lstStyle/>
+            <a:p/>
+          </p:txBody>
+        </p:sp>
+        <p:sp>
+          <p:nvSpPr>
+            <p:cNvPr id="306" name="pt91"/>
+            <p:cNvSpPr/>
+            <p:nvPr/>
+          </p:nvSpPr>
+          <p:spPr>
+            <a:xfrm>
+              <a:off x="7072769" y="2786503"/>
+              <a:ext cx="87688" cy="87688"/>
+            </a:xfrm>
+            <a:prstGeom prst="ellipse">
+              <a:avLst/>
+            </a:prstGeom>
+            <a:solidFill>
+              <a:srgbClr val="111111">
+                <a:alpha val="100000"/>
+              </a:srgbClr>
+            </a:solidFill>
+            <a:ln w="9818" cap="rnd">
+              <a:solidFill>
+                <a:srgbClr val="111111">
+                  <a:alpha val="100000"/>
+                </a:srgbClr>
+              </a:solidFill>
+              <a:prstDash val="solid"/>
+              <a:round/>
+            </a:ln>
+          </p:spPr>
+          <p:txBody>
+            <a:bodyPr/>
+            <a:lstStyle/>
+            <a:p/>
+          </p:txBody>
+        </p:sp>
+        <p:sp>
+          <p:nvSpPr>
+            <p:cNvPr id="307" name="pt92"/>
+            <p:cNvSpPr/>
+            <p:nvPr/>
+          </p:nvSpPr>
+          <p:spPr>
+            <a:xfrm>
+              <a:off x="7021353" y="2648674"/>
+              <a:ext cx="133037" cy="133037"/>
+            </a:xfrm>
+            <a:prstGeom prst="ellipse">
+              <a:avLst/>
+            </a:prstGeom>
+            <a:solidFill>
+              <a:srgbClr val="164BCE">
+                <a:alpha val="100000"/>
+              </a:srgbClr>
+            </a:solidFill>
+            <a:ln w="9818" cap="rnd">
+              <a:solidFill>
+                <a:srgbClr val="164BCE">
+                  <a:alpha val="100000"/>
+                </a:srgbClr>
+              </a:solidFill>
+              <a:prstDash val="solid"/>
+              <a:round/>
+            </a:ln>
+          </p:spPr>
+          <p:txBody>
+            <a:bodyPr/>
+            <a:lstStyle/>
+            <a:p/>
+          </p:txBody>
+        </p:sp>
+        <p:sp>
+          <p:nvSpPr>
+            <p:cNvPr id="308" name="pt93"/>
+            <p:cNvSpPr/>
+            <p:nvPr/>
+          </p:nvSpPr>
+          <p:spPr>
+            <a:xfrm>
+              <a:off x="7016585" y="2547968"/>
+              <a:ext cx="104140" cy="104140"/>
+            </a:xfrm>
+            <a:prstGeom prst="ellipse">
+              <a:avLst/>
+            </a:prstGeom>
+            <a:solidFill>
+              <a:srgbClr val="111111">
+                <a:alpha val="100000"/>
+              </a:srgbClr>
+            </a:solidFill>
+            <a:ln w="9818" cap="rnd">
+              <a:solidFill>
+                <a:srgbClr val="111111">
+                  <a:alpha val="100000"/>
+                </a:srgbClr>
+              </a:solidFill>
+              <a:prstDash val="solid"/>
+              <a:round/>
+            </a:ln>
+          </p:spPr>
+          <p:txBody>
+            <a:bodyPr/>
+            <a:lstStyle/>
+            <a:p/>
+          </p:txBody>
+        </p:sp>
+        <p:sp>
+          <p:nvSpPr>
+            <p:cNvPr id="309" name="pt94"/>
+            <p:cNvSpPr/>
+            <p:nvPr/>
+          </p:nvSpPr>
+          <p:spPr>
+            <a:xfrm>
+              <a:off x="7027978" y="2448870"/>
+              <a:ext cx="72027" cy="72027"/>
+            </a:xfrm>
+            <a:prstGeom prst="ellipse">
+              <a:avLst/>
+            </a:prstGeom>
+            <a:solidFill>
+              <a:srgbClr val="164BCE">
+                <a:alpha val="100000"/>
+              </a:srgbClr>
+            </a:solidFill>
+            <a:ln w="9818" cap="rnd">
+              <a:solidFill>
+                <a:srgbClr val="164BCE">
+                  <a:alpha val="100000"/>
+                </a:srgbClr>
+              </a:solidFill>
+              <a:prstDash val="solid"/>
+              <a:round/>
+            </a:ln>
+          </p:spPr>
+          <p:txBody>
+            <a:bodyPr/>
+            <a:lstStyle/>
+            <a:p/>
+          </p:txBody>
+        </p:sp>
+        <p:sp>
+          <p:nvSpPr>
+            <p:cNvPr id="310" name="pt95"/>
+            <p:cNvSpPr/>
+            <p:nvPr/>
+          </p:nvSpPr>
+          <p:spPr>
+            <a:xfrm>
+              <a:off x="7025681" y="2331419"/>
+              <a:ext cx="76620" cy="76620"/>
+            </a:xfrm>
+            <a:prstGeom prst="ellipse">
+              <a:avLst/>
+            </a:prstGeom>
+            <a:solidFill>
+              <a:srgbClr val="164BCE">
+                <a:alpha val="100000"/>
+              </a:srgbClr>
+            </a:solidFill>
+            <a:ln w="9818" cap="rnd">
+              <a:solidFill>
+                <a:srgbClr val="164BCE">
+                  <a:alpha val="100000"/>
+                </a:srgbClr>
+              </a:solidFill>
+              <a:prstDash val="solid"/>
+              <a:round/>
+            </a:ln>
+          </p:spPr>
+          <p:txBody>
+            <a:bodyPr/>
+            <a:lstStyle/>
+            <a:p/>
+          </p:txBody>
+        </p:sp>
+        <p:sp>
+          <p:nvSpPr>
+            <p:cNvPr id="311" name="pt96"/>
+            <p:cNvSpPr/>
+            <p:nvPr/>
+          </p:nvSpPr>
+          <p:spPr>
+            <a:xfrm>
+              <a:off x="7021829" y="2212412"/>
+              <a:ext cx="84324" cy="84324"/>
             </a:xfrm>
             <a:prstGeom prst="ellipse">
               <a:avLst/>
@@ -13238,14 +13833,14 @@
         </p:sp>
         <p:sp>
           <p:nvSpPr>
-            <p:cNvPr id="295" name="pt80"/>
-            <p:cNvSpPr/>
-            <p:nvPr/>
-          </p:nvSpPr>
-          <p:spPr>
-            <a:xfrm>
-              <a:off x="7158323" y="4058737"/>
-              <a:ext cx="76620" cy="76620"/>
+            <p:cNvPr id="312" name="pt97"/>
+            <p:cNvSpPr/>
+            <p:nvPr/>
+          </p:nvSpPr>
+          <p:spPr>
+            <a:xfrm>
+              <a:off x="7018582" y="2094010"/>
+              <a:ext cx="90819" cy="90819"/>
             </a:xfrm>
             <a:prstGeom prst="ellipse">
               <a:avLst/>
@@ -13273,14 +13868,154 @@
         </p:sp>
         <p:sp>
           <p:nvSpPr>
-            <p:cNvPr id="296" name="pt81"/>
-            <p:cNvSpPr/>
-            <p:nvPr/>
-          </p:nvSpPr>
-          <p:spPr>
-            <a:xfrm>
-              <a:off x="7146573" y="3933622"/>
-              <a:ext cx="96542" cy="96542"/>
+            <p:cNvPr id="313" name="pt98"/>
+            <p:cNvSpPr/>
+            <p:nvPr/>
+          </p:nvSpPr>
+          <p:spPr>
+            <a:xfrm>
+              <a:off x="7002622" y="1973408"/>
+              <a:ext cx="101715" cy="101715"/>
+            </a:xfrm>
+            <a:prstGeom prst="ellipse">
+              <a:avLst/>
+            </a:prstGeom>
+            <a:solidFill>
+              <a:srgbClr val="164BCE">
+                <a:alpha val="100000"/>
+              </a:srgbClr>
+            </a:solidFill>
+            <a:ln w="9818" cap="rnd">
+              <a:solidFill>
+                <a:srgbClr val="164BCE">
+                  <a:alpha val="100000"/>
+                </a:srgbClr>
+              </a:solidFill>
+              <a:prstDash val="solid"/>
+              <a:round/>
+            </a:ln>
+          </p:spPr>
+          <p:txBody>
+            <a:bodyPr/>
+            <a:lstStyle/>
+            <a:p/>
+          </p:txBody>
+        </p:sp>
+        <p:sp>
+          <p:nvSpPr>
+            <p:cNvPr id="314" name="pt99"/>
+            <p:cNvSpPr/>
+            <p:nvPr/>
+          </p:nvSpPr>
+          <p:spPr>
+            <a:xfrm>
+              <a:off x="7009635" y="1865267"/>
+              <a:ext cx="87688" cy="87688"/>
+            </a:xfrm>
+            <a:prstGeom prst="ellipse">
+              <a:avLst/>
+            </a:prstGeom>
+            <a:solidFill>
+              <a:srgbClr val="164BCE">
+                <a:alpha val="100000"/>
+              </a:srgbClr>
+            </a:solidFill>
+            <a:ln w="9818" cap="rnd">
+              <a:solidFill>
+                <a:srgbClr val="164BCE">
+                  <a:alpha val="100000"/>
+                </a:srgbClr>
+              </a:solidFill>
+              <a:prstDash val="solid"/>
+              <a:round/>
+            </a:ln>
+          </p:spPr>
+          <p:txBody>
+            <a:bodyPr/>
+            <a:lstStyle/>
+            <a:p/>
+          </p:txBody>
+        </p:sp>
+        <p:sp>
+          <p:nvSpPr>
+            <p:cNvPr id="315" name="pt100"/>
+            <p:cNvSpPr/>
+            <p:nvPr/>
+          </p:nvSpPr>
+          <p:spPr>
+            <a:xfrm>
+              <a:off x="6995949" y="1736426"/>
+              <a:ext cx="115059" cy="115059"/>
+            </a:xfrm>
+            <a:prstGeom prst="ellipse">
+              <a:avLst/>
+            </a:prstGeom>
+            <a:solidFill>
+              <a:srgbClr val="159230">
+                <a:alpha val="100000"/>
+              </a:srgbClr>
+            </a:solidFill>
+            <a:ln w="9818" cap="rnd">
+              <a:solidFill>
+                <a:srgbClr val="159230">
+                  <a:alpha val="100000"/>
+                </a:srgbClr>
+              </a:solidFill>
+              <a:prstDash val="solid"/>
+              <a:round/>
+            </a:ln>
+          </p:spPr>
+          <p:txBody>
+            <a:bodyPr/>
+            <a:lstStyle/>
+            <a:p/>
+          </p:txBody>
+        </p:sp>
+        <p:sp>
+          <p:nvSpPr>
+            <p:cNvPr id="316" name="pt101"/>
+            <p:cNvSpPr/>
+            <p:nvPr/>
+          </p:nvSpPr>
+          <p:spPr>
+            <a:xfrm>
+              <a:off x="6980364" y="1642788"/>
+              <a:ext cx="72027" cy="72027"/>
+            </a:xfrm>
+            <a:prstGeom prst="ellipse">
+              <a:avLst/>
+            </a:prstGeom>
+            <a:solidFill>
+              <a:srgbClr val="164BCE">
+                <a:alpha val="100000"/>
+              </a:srgbClr>
+            </a:solidFill>
+            <a:ln w="9818" cap="rnd">
+              <a:solidFill>
+                <a:srgbClr val="164BCE">
+                  <a:alpha val="100000"/>
+                </a:srgbClr>
+              </a:solidFill>
+              <a:prstDash val="solid"/>
+              <a:round/>
+            </a:ln>
+          </p:spPr>
+          <p:txBody>
+            <a:bodyPr/>
+            <a:lstStyle/>
+            <a:p/>
+          </p:txBody>
+        </p:sp>
+        <p:sp>
+          <p:nvSpPr>
+            <p:cNvPr id="317" name="pt102"/>
+            <p:cNvSpPr/>
+            <p:nvPr/>
+          </p:nvSpPr>
+          <p:spPr>
+            <a:xfrm>
+              <a:off x="6918786" y="1491056"/>
+              <a:ext cx="145181" cy="145181"/>
             </a:xfrm>
             <a:prstGeom prst="ellipse">
               <a:avLst/>
@@ -13308,14 +14043,259 @@
         </p:sp>
         <p:sp>
           <p:nvSpPr>
-            <p:cNvPr id="297" name="pt82"/>
-            <p:cNvSpPr/>
-            <p:nvPr/>
-          </p:nvSpPr>
-          <p:spPr>
-            <a:xfrm>
-              <a:off x="7160946" y="3833449"/>
-              <a:ext cx="66579" cy="66579"/>
+            <p:cNvPr id="318" name="pt103"/>
+            <p:cNvSpPr/>
+            <p:nvPr/>
+          </p:nvSpPr>
+          <p:spPr>
+            <a:xfrm>
+              <a:off x="6943110" y="1410182"/>
+              <a:ext cx="76620" cy="76620"/>
+            </a:xfrm>
+            <a:prstGeom prst="ellipse">
+              <a:avLst/>
+            </a:prstGeom>
+            <a:solidFill>
+              <a:srgbClr val="164BCE">
+                <a:alpha val="100000"/>
+              </a:srgbClr>
+            </a:solidFill>
+            <a:ln w="9818" cap="rnd">
+              <a:solidFill>
+                <a:srgbClr val="164BCE">
+                  <a:alpha val="100000"/>
+                </a:srgbClr>
+              </a:solidFill>
+              <a:prstDash val="solid"/>
+              <a:round/>
+            </a:ln>
+          </p:spPr>
+          <p:txBody>
+            <a:bodyPr/>
+            <a:lstStyle/>
+            <a:p/>
+          </p:txBody>
+        </p:sp>
+        <p:sp>
+          <p:nvSpPr>
+            <p:cNvPr id="319" name="pt104"/>
+            <p:cNvSpPr/>
+            <p:nvPr/>
+          </p:nvSpPr>
+          <p:spPr>
+            <a:xfrm>
+              <a:off x="6885087" y="1260747"/>
+              <a:ext cx="145181" cy="145181"/>
+            </a:xfrm>
+            <a:prstGeom prst="ellipse">
+              <a:avLst/>
+            </a:prstGeom>
+            <a:solidFill>
+              <a:srgbClr val="164BCE">
+                <a:alpha val="100000"/>
+              </a:srgbClr>
+            </a:solidFill>
+            <a:ln w="9818" cap="rnd">
+              <a:solidFill>
+                <a:srgbClr val="164BCE">
+                  <a:alpha val="100000"/>
+                </a:srgbClr>
+              </a:solidFill>
+              <a:prstDash val="solid"/>
+              <a:round/>
+            </a:ln>
+          </p:spPr>
+          <p:txBody>
+            <a:bodyPr/>
+            <a:lstStyle/>
+            <a:p/>
+          </p:txBody>
+        </p:sp>
+        <p:sp>
+          <p:nvSpPr>
+            <p:cNvPr id="320" name="pt105"/>
+            <p:cNvSpPr/>
+            <p:nvPr/>
+          </p:nvSpPr>
+          <p:spPr>
+            <a:xfrm>
+              <a:off x="6905872" y="1177850"/>
+              <a:ext cx="80666" cy="80666"/>
+            </a:xfrm>
+            <a:prstGeom prst="ellipse">
+              <a:avLst/>
+            </a:prstGeom>
+            <a:solidFill>
+              <a:srgbClr val="164BCE">
+                <a:alpha val="100000"/>
+              </a:srgbClr>
+            </a:solidFill>
+            <a:ln w="9818" cap="rnd">
+              <a:solidFill>
+                <a:srgbClr val="164BCE">
+                  <a:alpha val="100000"/>
+                </a:srgbClr>
+              </a:solidFill>
+              <a:prstDash val="solid"/>
+              <a:round/>
+            </a:ln>
+          </p:spPr>
+          <p:txBody>
+            <a:bodyPr/>
+            <a:lstStyle/>
+            <a:p/>
+          </p:txBody>
+        </p:sp>
+        <p:sp>
+          <p:nvSpPr>
+            <p:cNvPr id="321" name="pt106"/>
+            <p:cNvSpPr/>
+            <p:nvPr/>
+          </p:nvSpPr>
+          <p:spPr>
+            <a:xfrm>
+              <a:off x="6899133" y="1059185"/>
+              <a:ext cx="87688" cy="87688"/>
+            </a:xfrm>
+            <a:prstGeom prst="ellipse">
+              <a:avLst/>
+            </a:prstGeom>
+            <a:solidFill>
+              <a:srgbClr val="164BCE">
+                <a:alpha val="100000"/>
+              </a:srgbClr>
+            </a:solidFill>
+            <a:ln w="9818" cap="rnd">
+              <a:solidFill>
+                <a:srgbClr val="164BCE">
+                  <a:alpha val="100000"/>
+                </a:srgbClr>
+              </a:solidFill>
+              <a:prstDash val="solid"/>
+              <a:round/>
+            </a:ln>
+          </p:spPr>
+          <p:txBody>
+            <a:bodyPr/>
+            <a:lstStyle/>
+            <a:p/>
+          </p:txBody>
+        </p:sp>
+        <p:sp>
+          <p:nvSpPr>
+            <p:cNvPr id="322" name="pt107"/>
+            <p:cNvSpPr/>
+            <p:nvPr/>
+          </p:nvSpPr>
+          <p:spPr>
+            <a:xfrm>
+              <a:off x="6883428" y="947541"/>
+              <a:ext cx="80666" cy="80666"/>
+            </a:xfrm>
+            <a:prstGeom prst="ellipse">
+              <a:avLst/>
+            </a:prstGeom>
+            <a:solidFill>
+              <a:srgbClr val="164BCE">
+                <a:alpha val="100000"/>
+              </a:srgbClr>
+            </a:solidFill>
+            <a:ln w="9818" cap="rnd">
+              <a:solidFill>
+                <a:srgbClr val="164BCE">
+                  <a:alpha val="100000"/>
+                </a:srgbClr>
+              </a:solidFill>
+              <a:prstDash val="solid"/>
+              <a:round/>
+            </a:ln>
+          </p:spPr>
+          <p:txBody>
+            <a:bodyPr/>
+            <a:lstStyle/>
+            <a:p/>
+          </p:txBody>
+        </p:sp>
+        <p:sp>
+          <p:nvSpPr>
+            <p:cNvPr id="323" name="pt108"/>
+            <p:cNvSpPr/>
+            <p:nvPr/>
+          </p:nvSpPr>
+          <p:spPr>
+            <a:xfrm>
+              <a:off x="6840731" y="827310"/>
+              <a:ext cx="90819" cy="90819"/>
+            </a:xfrm>
+            <a:prstGeom prst="ellipse">
+              <a:avLst/>
+            </a:prstGeom>
+            <a:solidFill>
+              <a:srgbClr val="164BCE">
+                <a:alpha val="100000"/>
+              </a:srgbClr>
+            </a:solidFill>
+            <a:ln w="9818" cap="rnd">
+              <a:solidFill>
+                <a:srgbClr val="164BCE">
+                  <a:alpha val="100000"/>
+                </a:srgbClr>
+              </a:solidFill>
+              <a:prstDash val="solid"/>
+              <a:round/>
+            </a:ln>
+          </p:spPr>
+          <p:txBody>
+            <a:bodyPr/>
+            <a:lstStyle/>
+            <a:p/>
+          </p:txBody>
+        </p:sp>
+        <p:sp>
+          <p:nvSpPr>
+            <p:cNvPr id="324" name="pt109"/>
+            <p:cNvSpPr/>
+            <p:nvPr/>
+          </p:nvSpPr>
+          <p:spPr>
+            <a:xfrm>
+              <a:off x="6806619" y="719255"/>
+              <a:ext cx="76620" cy="76620"/>
+            </a:xfrm>
+            <a:prstGeom prst="ellipse">
+              <a:avLst/>
+            </a:prstGeom>
+            <a:solidFill>
+              <a:srgbClr val="164BCE">
+                <a:alpha val="100000"/>
+              </a:srgbClr>
+            </a:solidFill>
+            <a:ln w="9818" cap="rnd">
+              <a:solidFill>
+                <a:srgbClr val="164BCE">
+                  <a:alpha val="100000"/>
+                </a:srgbClr>
+              </a:solidFill>
+              <a:prstDash val="solid"/>
+              <a:round/>
+            </a:ln>
+          </p:spPr>
+          <p:txBody>
+            <a:bodyPr/>
+            <a:lstStyle/>
+            <a:p/>
+          </p:txBody>
+        </p:sp>
+        <p:sp>
+          <p:nvSpPr>
+            <p:cNvPr id="325" name="pt110"/>
+            <p:cNvSpPr/>
+            <p:nvPr/>
+          </p:nvSpPr>
+          <p:spPr>
+            <a:xfrm>
+              <a:off x="6773590" y="589174"/>
+              <a:ext cx="106472" cy="106472"/>
             </a:xfrm>
             <a:prstGeom prst="ellipse">
               <a:avLst/>
@@ -13343,14 +14323,14 @@
         </p:sp>
         <p:sp>
           <p:nvSpPr>
-            <p:cNvPr id="298" name="pt83"/>
-            <p:cNvSpPr/>
-            <p:nvPr/>
-          </p:nvSpPr>
-          <p:spPr>
-            <a:xfrm>
-              <a:off x="7150126" y="3711251"/>
-              <a:ext cx="80666" cy="80666"/>
+            <p:cNvPr id="326" name="pt111"/>
+            <p:cNvSpPr/>
+            <p:nvPr/>
+          </p:nvSpPr>
+          <p:spPr>
+            <a:xfrm>
+              <a:off x="6544368" y="480376"/>
+              <a:ext cx="93760" cy="93760"/>
             </a:xfrm>
             <a:prstGeom prst="ellipse">
               <a:avLst/>
@@ -13378,14 +14358,14 @@
         </p:sp>
         <p:sp>
           <p:nvSpPr>
-            <p:cNvPr id="299" name="pt84"/>
-            <p:cNvSpPr/>
-            <p:nvPr/>
-          </p:nvSpPr>
-          <p:spPr>
-            <a:xfrm>
-              <a:off x="7117342" y="3582067"/>
-              <a:ext cx="108723" cy="108723"/>
+            <p:cNvPr id="327" name="pt112"/>
+            <p:cNvSpPr/>
+            <p:nvPr/>
+          </p:nvSpPr>
+          <p:spPr>
+            <a:xfrm>
+              <a:off x="6409044" y="336729"/>
+              <a:ext cx="150744" cy="150744"/>
             </a:xfrm>
             <a:prstGeom prst="ellipse">
               <a:avLst/>
@@ -13413,993 +14393,13 @@
         </p:sp>
         <p:sp>
           <p:nvSpPr>
-            <p:cNvPr id="300" name="pt85"/>
-            <p:cNvSpPr/>
-            <p:nvPr/>
-          </p:nvSpPr>
-          <p:spPr>
-            <a:xfrm>
-              <a:off x="7116411" y="3485261"/>
-              <a:ext cx="72027" cy="72027"/>
-            </a:xfrm>
-            <a:prstGeom prst="ellipse">
-              <a:avLst/>
-            </a:prstGeom>
-            <a:solidFill>
-              <a:srgbClr val="164BCE">
-                <a:alpha val="100000"/>
-              </a:srgbClr>
-            </a:solidFill>
-            <a:ln w="9818" cap="rnd">
-              <a:solidFill>
-                <a:srgbClr val="164BCE">
-                  <a:alpha val="100000"/>
-                </a:srgbClr>
-              </a:solidFill>
-              <a:prstDash val="solid"/>
-              <a:round/>
-            </a:ln>
-          </p:spPr>
-          <p:txBody>
-            <a:bodyPr/>
-            <a:lstStyle/>
-            <a:p/>
-          </p:txBody>
-        </p:sp>
-        <p:sp>
-          <p:nvSpPr>
-            <p:cNvPr id="301" name="pt86"/>
-            <p:cNvSpPr/>
-            <p:nvPr/>
-          </p:nvSpPr>
-          <p:spPr>
-            <a:xfrm>
-              <a:off x="7102404" y="3367810"/>
-              <a:ext cx="76620" cy="76620"/>
-            </a:xfrm>
-            <a:prstGeom prst="ellipse">
-              <a:avLst/>
-            </a:prstGeom>
-            <a:solidFill>
-              <a:srgbClr val="164BCE">
-                <a:alpha val="100000"/>
-              </a:srgbClr>
-            </a:solidFill>
-            <a:ln w="9818" cap="rnd">
-              <a:solidFill>
-                <a:srgbClr val="164BCE">
-                  <a:alpha val="100000"/>
-                </a:srgbClr>
-              </a:solidFill>
-              <a:prstDash val="solid"/>
-              <a:round/>
-            </a:ln>
-          </p:spPr>
-          <p:txBody>
-            <a:bodyPr/>
-            <a:lstStyle/>
-            <a:p/>
-          </p:txBody>
-        </p:sp>
-        <p:sp>
-          <p:nvSpPr>
-            <p:cNvPr id="302" name="pt87"/>
-            <p:cNvSpPr/>
-            <p:nvPr/>
-          </p:nvSpPr>
-          <p:spPr>
-            <a:xfrm>
-              <a:off x="7100381" y="3250632"/>
-              <a:ext cx="80666" cy="80666"/>
-            </a:xfrm>
-            <a:prstGeom prst="ellipse">
-              <a:avLst/>
-            </a:prstGeom>
-            <a:solidFill>
-              <a:srgbClr val="164BCE">
-                <a:alpha val="100000"/>
-              </a:srgbClr>
-            </a:solidFill>
-            <a:ln w="9818" cap="rnd">
-              <a:solidFill>
-                <a:srgbClr val="164BCE">
-                  <a:alpha val="100000"/>
-                </a:srgbClr>
-              </a:solidFill>
-              <a:prstDash val="solid"/>
-              <a:round/>
-            </a:ln>
-          </p:spPr>
-          <p:txBody>
-            <a:bodyPr/>
-            <a:lstStyle/>
-            <a:p/>
-          </p:txBody>
-        </p:sp>
-        <p:sp>
-          <p:nvSpPr>
-            <p:cNvPr id="303" name="pt88"/>
-            <p:cNvSpPr/>
-            <p:nvPr/>
-          </p:nvSpPr>
-          <p:spPr>
-            <a:xfrm>
-              <a:off x="7076997" y="3113540"/>
-              <a:ext cx="124541" cy="124541"/>
-            </a:xfrm>
-            <a:prstGeom prst="ellipse">
-              <a:avLst/>
-            </a:prstGeom>
-            <a:solidFill>
-              <a:srgbClr val="164BCE">
-                <a:alpha val="100000"/>
-              </a:srgbClr>
-            </a:solidFill>
-            <a:ln w="9818" cap="rnd">
-              <a:solidFill>
-                <a:srgbClr val="164BCE">
-                  <a:alpha val="100000"/>
-                </a:srgbClr>
-              </a:solidFill>
-              <a:prstDash val="solid"/>
-              <a:round/>
-            </a:ln>
-          </p:spPr>
-          <p:txBody>
-            <a:bodyPr/>
-            <a:lstStyle/>
-            <a:p/>
-          </p:txBody>
-        </p:sp>
-        <p:sp>
-          <p:nvSpPr>
-            <p:cNvPr id="304" name="pt89"/>
-            <p:cNvSpPr/>
-            <p:nvPr/>
-          </p:nvSpPr>
-          <p:spPr>
-            <a:xfrm>
-              <a:off x="7104497" y="3027367"/>
-              <a:ext cx="66579" cy="66579"/>
-            </a:xfrm>
-            <a:prstGeom prst="ellipse">
-              <a:avLst/>
-            </a:prstGeom>
-            <a:solidFill>
-              <a:srgbClr val="164BCE">
-                <a:alpha val="100000"/>
-              </a:srgbClr>
-            </a:solidFill>
-            <a:ln w="9818" cap="rnd">
-              <a:solidFill>
-                <a:srgbClr val="164BCE">
-                  <a:alpha val="100000"/>
-                </a:srgbClr>
-              </a:solidFill>
-              <a:prstDash val="solid"/>
-              <a:round/>
-            </a:ln>
-          </p:spPr>
-          <p:txBody>
-            <a:bodyPr/>
-            <a:lstStyle/>
-            <a:p/>
-          </p:txBody>
-        </p:sp>
-        <p:sp>
-          <p:nvSpPr>
-            <p:cNvPr id="305" name="pt90"/>
-            <p:cNvSpPr/>
-            <p:nvPr/>
-          </p:nvSpPr>
-          <p:spPr>
-            <a:xfrm>
-              <a:off x="7052210" y="2875100"/>
-              <a:ext cx="140803" cy="140803"/>
-            </a:xfrm>
-            <a:prstGeom prst="ellipse">
-              <a:avLst/>
-            </a:prstGeom>
-            <a:solidFill>
-              <a:srgbClr val="164BCE">
-                <a:alpha val="100000"/>
-              </a:srgbClr>
-            </a:solidFill>
-            <a:ln w="9818" cap="rnd">
-              <a:solidFill>
-                <a:srgbClr val="164BCE">
-                  <a:alpha val="100000"/>
-                </a:srgbClr>
-              </a:solidFill>
-              <a:prstDash val="solid"/>
-              <a:round/>
-            </a:ln>
-          </p:spPr>
-          <p:txBody>
-            <a:bodyPr/>
-            <a:lstStyle/>
-            <a:p/>
-          </p:txBody>
-        </p:sp>
-        <p:sp>
-          <p:nvSpPr>
-            <p:cNvPr id="306" name="pt91"/>
-            <p:cNvSpPr/>
-            <p:nvPr/>
-          </p:nvSpPr>
-          <p:spPr>
-            <a:xfrm>
-              <a:off x="7061297" y="2786503"/>
-              <a:ext cx="87688" cy="87688"/>
-            </a:xfrm>
-            <a:prstGeom prst="ellipse">
-              <a:avLst/>
-            </a:prstGeom>
-            <a:solidFill>
-              <a:srgbClr val="111111">
-                <a:alpha val="100000"/>
-              </a:srgbClr>
-            </a:solidFill>
-            <a:ln w="9818" cap="rnd">
-              <a:solidFill>
-                <a:srgbClr val="111111">
-                  <a:alpha val="100000"/>
-                </a:srgbClr>
-              </a:solidFill>
-              <a:prstDash val="solid"/>
-              <a:round/>
-            </a:ln>
-          </p:spPr>
-          <p:txBody>
-            <a:bodyPr/>
-            <a:lstStyle/>
-            <a:p/>
-          </p:txBody>
-        </p:sp>
-        <p:sp>
-          <p:nvSpPr>
-            <p:cNvPr id="307" name="pt92"/>
-            <p:cNvSpPr/>
-            <p:nvPr/>
-          </p:nvSpPr>
-          <p:spPr>
-            <a:xfrm>
-              <a:off x="7014354" y="2648674"/>
-              <a:ext cx="133037" cy="133037"/>
-            </a:xfrm>
-            <a:prstGeom prst="ellipse">
-              <a:avLst/>
-            </a:prstGeom>
-            <a:solidFill>
-              <a:srgbClr val="164BCE">
-                <a:alpha val="100000"/>
-              </a:srgbClr>
-            </a:solidFill>
-            <a:ln w="9818" cap="rnd">
-              <a:solidFill>
-                <a:srgbClr val="164BCE">
-                  <a:alpha val="100000"/>
-                </a:srgbClr>
-              </a:solidFill>
-              <a:prstDash val="solid"/>
-              <a:round/>
-            </a:ln>
-          </p:spPr>
-          <p:txBody>
-            <a:bodyPr/>
-            <a:lstStyle/>
-            <a:p/>
-          </p:txBody>
-        </p:sp>
-        <p:sp>
-          <p:nvSpPr>
-            <p:cNvPr id="308" name="pt93"/>
-            <p:cNvSpPr/>
-            <p:nvPr/>
-          </p:nvSpPr>
-          <p:spPr>
-            <a:xfrm>
-              <a:off x="7020645" y="2561728"/>
-              <a:ext cx="76620" cy="76620"/>
-            </a:xfrm>
-            <a:prstGeom prst="ellipse">
-              <a:avLst/>
-            </a:prstGeom>
-            <a:solidFill>
-              <a:srgbClr val="164BCE">
-                <a:alpha val="100000"/>
-              </a:srgbClr>
-            </a:solidFill>
-            <a:ln w="9818" cap="rnd">
-              <a:solidFill>
-                <a:srgbClr val="164BCE">
-                  <a:alpha val="100000"/>
-                </a:srgbClr>
-              </a:solidFill>
-              <a:prstDash val="solid"/>
-              <a:round/>
-            </a:ln>
-          </p:spPr>
-          <p:txBody>
-            <a:bodyPr/>
-            <a:lstStyle/>
-            <a:p/>
-          </p:txBody>
-        </p:sp>
-        <p:sp>
-          <p:nvSpPr>
-            <p:cNvPr id="309" name="pt94"/>
-            <p:cNvSpPr/>
-            <p:nvPr/>
-          </p:nvSpPr>
-          <p:spPr>
-            <a:xfrm>
-              <a:off x="7006885" y="2432814"/>
-              <a:ext cx="104140" cy="104140"/>
-            </a:xfrm>
-            <a:prstGeom prst="ellipse">
-              <a:avLst/>
-            </a:prstGeom>
-            <a:solidFill>
-              <a:srgbClr val="111111">
-                <a:alpha val="100000"/>
-              </a:srgbClr>
-            </a:solidFill>
-            <a:ln w="9818" cap="rnd">
-              <a:solidFill>
-                <a:srgbClr val="111111">
-                  <a:alpha val="100000"/>
-                </a:srgbClr>
-              </a:solidFill>
-              <a:prstDash val="solid"/>
-              <a:round/>
-            </a:ln>
-          </p:spPr>
-          <p:txBody>
-            <a:bodyPr/>
-            <a:lstStyle/>
-            <a:p/>
-          </p:txBody>
-        </p:sp>
-        <p:sp>
-          <p:nvSpPr>
-            <p:cNvPr id="310" name="pt95"/>
-            <p:cNvSpPr/>
-            <p:nvPr/>
-          </p:nvSpPr>
-          <p:spPr>
-            <a:xfrm>
-              <a:off x="7017466" y="2333715"/>
-              <a:ext cx="72027" cy="72027"/>
-            </a:xfrm>
-            <a:prstGeom prst="ellipse">
-              <a:avLst/>
-            </a:prstGeom>
-            <a:solidFill>
-              <a:srgbClr val="164BCE">
-                <a:alpha val="100000"/>
-              </a:srgbClr>
-            </a:solidFill>
-            <a:ln w="9818" cap="rnd">
-              <a:solidFill>
-                <a:srgbClr val="164BCE">
-                  <a:alpha val="100000"/>
-                </a:srgbClr>
-              </a:solidFill>
-              <a:prstDash val="solid"/>
-              <a:round/>
-            </a:ln>
-          </p:spPr>
-          <p:txBody>
-            <a:bodyPr/>
-            <a:lstStyle/>
-            <a:p/>
-          </p:txBody>
-        </p:sp>
-        <p:sp>
-          <p:nvSpPr>
-            <p:cNvPr id="311" name="pt96"/>
-            <p:cNvSpPr/>
-            <p:nvPr/>
-          </p:nvSpPr>
-          <p:spPr>
-            <a:xfrm>
-              <a:off x="7011317" y="2212412"/>
-              <a:ext cx="84324" cy="84324"/>
-            </a:xfrm>
-            <a:prstGeom prst="ellipse">
-              <a:avLst/>
-            </a:prstGeom>
-            <a:solidFill>
-              <a:srgbClr val="159230">
-                <a:alpha val="100000"/>
-              </a:srgbClr>
-            </a:solidFill>
-            <a:ln w="9818" cap="rnd">
-              <a:solidFill>
-                <a:srgbClr val="159230">
-                  <a:alpha val="100000"/>
-                </a:srgbClr>
-              </a:solidFill>
-              <a:prstDash val="solid"/>
-              <a:round/>
-            </a:ln>
-          </p:spPr>
-          <p:txBody>
-            <a:bodyPr/>
-            <a:lstStyle/>
-            <a:p/>
-          </p:txBody>
-        </p:sp>
-        <p:sp>
-          <p:nvSpPr>
-            <p:cNvPr id="312" name="pt97"/>
-            <p:cNvSpPr/>
-            <p:nvPr/>
-          </p:nvSpPr>
-          <p:spPr>
-            <a:xfrm>
-              <a:off x="7009635" y="2095576"/>
-              <a:ext cx="87688" cy="87688"/>
-            </a:xfrm>
-            <a:prstGeom prst="ellipse">
-              <a:avLst/>
-            </a:prstGeom>
-            <a:solidFill>
-              <a:srgbClr val="164BCE">
-                <a:alpha val="100000"/>
-              </a:srgbClr>
-            </a:solidFill>
-            <a:ln w="9818" cap="rnd">
-              <a:solidFill>
-                <a:srgbClr val="164BCE">
-                  <a:alpha val="100000"/>
-                </a:srgbClr>
-              </a:solidFill>
-              <a:prstDash val="solid"/>
-              <a:round/>
-            </a:ln>
-          </p:spPr>
-          <p:txBody>
-            <a:bodyPr/>
-            <a:lstStyle/>
-            <a:p/>
-          </p:txBody>
-        </p:sp>
-        <p:sp>
-          <p:nvSpPr>
-            <p:cNvPr id="313" name="pt98"/>
-            <p:cNvSpPr/>
-            <p:nvPr/>
-          </p:nvSpPr>
-          <p:spPr>
-            <a:xfrm>
-              <a:off x="7008069" y="1978856"/>
-              <a:ext cx="90819" cy="90819"/>
-            </a:xfrm>
-            <a:prstGeom prst="ellipse">
-              <a:avLst/>
-            </a:prstGeom>
-            <a:solidFill>
-              <a:srgbClr val="164BCE">
-                <a:alpha val="100000"/>
-              </a:srgbClr>
-            </a:solidFill>
-            <a:ln w="9818" cap="rnd">
-              <a:solidFill>
-                <a:srgbClr val="164BCE">
-                  <a:alpha val="100000"/>
-                </a:srgbClr>
-              </a:solidFill>
-              <a:prstDash val="solid"/>
-              <a:round/>
-            </a:ln>
-          </p:spPr>
-          <p:txBody>
-            <a:bodyPr/>
-            <a:lstStyle/>
-            <a:p/>
-          </p:txBody>
-        </p:sp>
-        <p:sp>
-          <p:nvSpPr>
-            <p:cNvPr id="314" name="pt99"/>
-            <p:cNvSpPr/>
-            <p:nvPr/>
-          </p:nvSpPr>
-          <p:spPr>
-            <a:xfrm>
-              <a:off x="6996624" y="1858253"/>
-              <a:ext cx="101715" cy="101715"/>
-            </a:xfrm>
-            <a:prstGeom prst="ellipse">
-              <a:avLst/>
-            </a:prstGeom>
-            <a:solidFill>
-              <a:srgbClr val="164BCE">
-                <a:alpha val="100000"/>
-              </a:srgbClr>
-            </a:solidFill>
-            <a:ln w="9818" cap="rnd">
-              <a:solidFill>
-                <a:srgbClr val="164BCE">
-                  <a:alpha val="100000"/>
-                </a:srgbClr>
-              </a:solidFill>
-              <a:prstDash val="solid"/>
-              <a:round/>
-            </a:ln>
-          </p:spPr>
-          <p:txBody>
-            <a:bodyPr/>
-            <a:lstStyle/>
-            <a:p/>
-          </p:txBody>
-        </p:sp>
-        <p:sp>
-          <p:nvSpPr>
-            <p:cNvPr id="315" name="pt100"/>
-            <p:cNvSpPr/>
-            <p:nvPr/>
-          </p:nvSpPr>
-          <p:spPr>
-            <a:xfrm>
-              <a:off x="6978227" y="1736426"/>
-              <a:ext cx="115059" cy="115059"/>
-            </a:xfrm>
-            <a:prstGeom prst="ellipse">
-              <a:avLst/>
-            </a:prstGeom>
-            <a:solidFill>
-              <a:srgbClr val="159230">
-                <a:alpha val="100000"/>
-              </a:srgbClr>
-            </a:solidFill>
-            <a:ln w="9818" cap="rnd">
-              <a:solidFill>
-                <a:srgbClr val="159230">
-                  <a:alpha val="100000"/>
-                </a:srgbClr>
-              </a:solidFill>
-              <a:prstDash val="solid"/>
-              <a:round/>
-            </a:ln>
-          </p:spPr>
-          <p:txBody>
-            <a:bodyPr/>
-            <a:lstStyle/>
-            <a:p/>
-          </p:txBody>
-        </p:sp>
-        <p:sp>
-          <p:nvSpPr>
-            <p:cNvPr id="316" name="pt101"/>
-            <p:cNvSpPr/>
-            <p:nvPr/>
-          </p:nvSpPr>
-          <p:spPr>
-            <a:xfrm>
-              <a:off x="6971517" y="1642788"/>
-              <a:ext cx="72027" cy="72027"/>
-            </a:xfrm>
-            <a:prstGeom prst="ellipse">
-              <a:avLst/>
-            </a:prstGeom>
-            <a:solidFill>
-              <a:srgbClr val="164BCE">
-                <a:alpha val="100000"/>
-              </a:srgbClr>
-            </a:solidFill>
-            <a:ln w="9818" cap="rnd">
-              <a:solidFill>
-                <a:srgbClr val="164BCE">
-                  <a:alpha val="100000"/>
-                </a:srgbClr>
-              </a:solidFill>
-              <a:prstDash val="solid"/>
-              <a:round/>
-            </a:ln>
-          </p:spPr>
-          <p:txBody>
-            <a:bodyPr/>
-            <a:lstStyle/>
-            <a:p/>
-          </p:txBody>
-        </p:sp>
-        <p:sp>
-          <p:nvSpPr>
-            <p:cNvPr id="317" name="pt102"/>
-            <p:cNvSpPr/>
-            <p:nvPr/>
-          </p:nvSpPr>
-          <p:spPr>
-            <a:xfrm>
-              <a:off x="6910602" y="1491056"/>
-              <a:ext cx="145181" cy="145181"/>
-            </a:xfrm>
-            <a:prstGeom prst="ellipse">
-              <a:avLst/>
-            </a:prstGeom>
-            <a:solidFill>
-              <a:srgbClr val="111111">
-                <a:alpha val="100000"/>
-              </a:srgbClr>
-            </a:solidFill>
-            <a:ln w="9818" cap="rnd">
-              <a:solidFill>
-                <a:srgbClr val="111111">
-                  <a:alpha val="100000"/>
-                </a:srgbClr>
-              </a:solidFill>
-              <a:prstDash val="solid"/>
-              <a:round/>
-            </a:ln>
-          </p:spPr>
-          <p:txBody>
-            <a:bodyPr/>
-            <a:lstStyle/>
-            <a:p/>
-          </p:txBody>
-        </p:sp>
-        <p:sp>
-          <p:nvSpPr>
-            <p:cNvPr id="318" name="pt103"/>
-            <p:cNvSpPr/>
-            <p:nvPr/>
-          </p:nvSpPr>
-          <p:spPr>
-            <a:xfrm>
-              <a:off x="6933410" y="1410182"/>
-              <a:ext cx="76620" cy="76620"/>
-            </a:xfrm>
-            <a:prstGeom prst="ellipse">
-              <a:avLst/>
-            </a:prstGeom>
-            <a:solidFill>
-              <a:srgbClr val="164BCE">
-                <a:alpha val="100000"/>
-              </a:srgbClr>
-            </a:solidFill>
-            <a:ln w="9818" cap="rnd">
-              <a:solidFill>
-                <a:srgbClr val="164BCE">
-                  <a:alpha val="100000"/>
-                </a:srgbClr>
-              </a:solidFill>
-              <a:prstDash val="solid"/>
-              <a:round/>
-            </a:ln>
-          </p:spPr>
-          <p:txBody>
-            <a:bodyPr/>
-            <a:lstStyle/>
-            <a:p/>
-          </p:txBody>
-        </p:sp>
-        <p:sp>
-          <p:nvSpPr>
-            <p:cNvPr id="319" name="pt104"/>
-            <p:cNvSpPr/>
-            <p:nvPr/>
-          </p:nvSpPr>
-          <p:spPr>
-            <a:xfrm>
-              <a:off x="6876685" y="1260747"/>
-              <a:ext cx="145181" cy="145181"/>
-            </a:xfrm>
-            <a:prstGeom prst="ellipse">
-              <a:avLst/>
-            </a:prstGeom>
-            <a:solidFill>
-              <a:srgbClr val="164BCE">
-                <a:alpha val="100000"/>
-              </a:srgbClr>
-            </a:solidFill>
-            <a:ln w="9818" cap="rnd">
-              <a:solidFill>
-                <a:srgbClr val="164BCE">
-                  <a:alpha val="100000"/>
-                </a:srgbClr>
-              </a:solidFill>
-              <a:prstDash val="solid"/>
-              <a:round/>
-            </a:ln>
-          </p:spPr>
-          <p:txBody>
-            <a:bodyPr/>
-            <a:lstStyle/>
-            <a:p/>
-          </p:txBody>
-        </p:sp>
-        <p:sp>
-          <p:nvSpPr>
-            <p:cNvPr id="320" name="pt105"/>
-            <p:cNvSpPr/>
-            <p:nvPr/>
-          </p:nvSpPr>
-          <p:spPr>
-            <a:xfrm>
-              <a:off x="6895645" y="1177850"/>
-              <a:ext cx="80666" cy="80666"/>
-            </a:xfrm>
-            <a:prstGeom prst="ellipse">
-              <a:avLst/>
-            </a:prstGeom>
-            <a:solidFill>
-              <a:srgbClr val="164BCE">
-                <a:alpha val="100000"/>
-              </a:srgbClr>
-            </a:solidFill>
-            <a:ln w="9818" cap="rnd">
-              <a:solidFill>
-                <a:srgbClr val="164BCE">
-                  <a:alpha val="100000"/>
-                </a:srgbClr>
-              </a:solidFill>
-              <a:prstDash val="solid"/>
-              <a:round/>
-            </a:ln>
-          </p:spPr>
-          <p:txBody>
-            <a:bodyPr/>
-            <a:lstStyle/>
-            <a:p/>
-          </p:txBody>
-        </p:sp>
-        <p:sp>
-          <p:nvSpPr>
-            <p:cNvPr id="321" name="pt106"/>
-            <p:cNvSpPr/>
-            <p:nvPr/>
-          </p:nvSpPr>
-          <p:spPr>
-            <a:xfrm>
-              <a:off x="6888319" y="1059185"/>
-              <a:ext cx="87688" cy="87688"/>
-            </a:xfrm>
-            <a:prstGeom prst="ellipse">
-              <a:avLst/>
-            </a:prstGeom>
-            <a:solidFill>
-              <a:srgbClr val="164BCE">
-                <a:alpha val="100000"/>
-              </a:srgbClr>
-            </a:solidFill>
-            <a:ln w="9818" cap="rnd">
-              <a:solidFill>
-                <a:srgbClr val="164BCE">
-                  <a:alpha val="100000"/>
-                </a:srgbClr>
-              </a:solidFill>
-              <a:prstDash val="solid"/>
-              <a:round/>
-            </a:ln>
-          </p:spPr>
-          <p:txBody>
-            <a:bodyPr/>
-            <a:lstStyle/>
-            <a:p/>
-          </p:txBody>
-        </p:sp>
-        <p:sp>
-          <p:nvSpPr>
-            <p:cNvPr id="322" name="pt107"/>
-            <p:cNvSpPr/>
-            <p:nvPr/>
-          </p:nvSpPr>
-          <p:spPr>
-            <a:xfrm>
-              <a:off x="6873728" y="947541"/>
-              <a:ext cx="80666" cy="80666"/>
-            </a:xfrm>
-            <a:prstGeom prst="ellipse">
-              <a:avLst/>
-            </a:prstGeom>
-            <a:solidFill>
-              <a:srgbClr val="164BCE">
-                <a:alpha val="100000"/>
-              </a:srgbClr>
-            </a:solidFill>
-            <a:ln w="9818" cap="rnd">
-              <a:solidFill>
-                <a:srgbClr val="164BCE">
-                  <a:alpha val="100000"/>
-                </a:srgbClr>
-              </a:solidFill>
-              <a:prstDash val="solid"/>
-              <a:round/>
-            </a:ln>
-          </p:spPr>
-          <p:txBody>
-            <a:bodyPr/>
-            <a:lstStyle/>
-            <a:p/>
-          </p:txBody>
-        </p:sp>
-        <p:sp>
-          <p:nvSpPr>
-            <p:cNvPr id="323" name="pt108"/>
-            <p:cNvSpPr/>
-            <p:nvPr/>
-          </p:nvSpPr>
-          <p:spPr>
-            <a:xfrm>
-              <a:off x="6828104" y="827310"/>
-              <a:ext cx="90819" cy="90819"/>
-            </a:xfrm>
-            <a:prstGeom prst="ellipse">
-              <a:avLst/>
-            </a:prstGeom>
-            <a:solidFill>
-              <a:srgbClr val="164BCE">
-                <a:alpha val="100000"/>
-              </a:srgbClr>
-            </a:solidFill>
-            <a:ln w="9818" cap="rnd">
-              <a:solidFill>
-                <a:srgbClr val="164BCE">
-                  <a:alpha val="100000"/>
-                </a:srgbClr>
-              </a:solidFill>
-              <a:prstDash val="solid"/>
-              <a:round/>
-            </a:ln>
-          </p:spPr>
-          <p:txBody>
-            <a:bodyPr/>
-            <a:lstStyle/>
-            <a:p/>
-          </p:txBody>
-        </p:sp>
-        <p:sp>
-          <p:nvSpPr>
-            <p:cNvPr id="324" name="pt109"/>
-            <p:cNvSpPr/>
-            <p:nvPr/>
-          </p:nvSpPr>
-          <p:spPr>
-            <a:xfrm>
-              <a:off x="6796392" y="719255"/>
-              <a:ext cx="76620" cy="76620"/>
-            </a:xfrm>
-            <a:prstGeom prst="ellipse">
-              <a:avLst/>
-            </a:prstGeom>
-            <a:solidFill>
-              <a:srgbClr val="164BCE">
-                <a:alpha val="100000"/>
-              </a:srgbClr>
-            </a:solidFill>
-            <a:ln w="9818" cap="rnd">
-              <a:solidFill>
-                <a:srgbClr val="164BCE">
-                  <a:alpha val="100000"/>
-                </a:srgbClr>
-              </a:solidFill>
-              <a:prstDash val="solid"/>
-              <a:round/>
-            </a:ln>
-          </p:spPr>
-          <p:txBody>
-            <a:bodyPr/>
-            <a:lstStyle/>
-            <a:p/>
-          </p:txBody>
-        </p:sp>
-        <p:sp>
-          <p:nvSpPr>
-            <p:cNvPr id="325" name="pt110"/>
-            <p:cNvSpPr/>
-            <p:nvPr/>
-          </p:nvSpPr>
-          <p:spPr>
-            <a:xfrm>
-              <a:off x="6756870" y="589174"/>
-              <a:ext cx="106472" cy="106472"/>
-            </a:xfrm>
-            <a:prstGeom prst="ellipse">
-              <a:avLst/>
-            </a:prstGeom>
-            <a:solidFill>
-              <a:srgbClr val="111111">
-                <a:alpha val="100000"/>
-              </a:srgbClr>
-            </a:solidFill>
-            <a:ln w="9818" cap="rnd">
-              <a:solidFill>
-                <a:srgbClr val="111111">
-                  <a:alpha val="100000"/>
-                </a:srgbClr>
-              </a:solidFill>
-              <a:prstDash val="solid"/>
-              <a:round/>
-            </a:ln>
-          </p:spPr>
-          <p:txBody>
-            <a:bodyPr/>
-            <a:lstStyle/>
-            <a:p/>
-          </p:txBody>
-        </p:sp>
-        <p:sp>
-          <p:nvSpPr>
-            <p:cNvPr id="326" name="pt111"/>
-            <p:cNvSpPr/>
-            <p:nvPr/>
-          </p:nvSpPr>
-          <p:spPr>
-            <a:xfrm>
-              <a:off x="6530548" y="480376"/>
-              <a:ext cx="93760" cy="93760"/>
-            </a:xfrm>
-            <a:prstGeom prst="ellipse">
-              <a:avLst/>
-            </a:prstGeom>
-            <a:solidFill>
-              <a:srgbClr val="111111">
-                <a:alpha val="100000"/>
-              </a:srgbClr>
-            </a:solidFill>
-            <a:ln w="9818" cap="rnd">
-              <a:solidFill>
-                <a:srgbClr val="111111">
-                  <a:alpha val="100000"/>
-                </a:srgbClr>
-              </a:solidFill>
-              <a:prstDash val="solid"/>
-              <a:round/>
-            </a:ln>
-          </p:spPr>
-          <p:txBody>
-            <a:bodyPr/>
-            <a:lstStyle/>
-            <a:p/>
-          </p:txBody>
-        </p:sp>
-        <p:sp>
-          <p:nvSpPr>
-            <p:cNvPr id="327" name="pt112"/>
-            <p:cNvSpPr/>
-            <p:nvPr/>
-          </p:nvSpPr>
-          <p:spPr>
-            <a:xfrm>
-              <a:off x="6380809" y="336729"/>
-              <a:ext cx="150744" cy="150744"/>
-            </a:xfrm>
-            <a:prstGeom prst="ellipse">
-              <a:avLst/>
-            </a:prstGeom>
-            <a:solidFill>
-              <a:srgbClr val="164BCE">
-                <a:alpha val="100000"/>
-              </a:srgbClr>
-            </a:solidFill>
-            <a:ln w="9818" cap="rnd">
-              <a:solidFill>
-                <a:srgbClr val="164BCE">
-                  <a:alpha val="100000"/>
-                </a:srgbClr>
-              </a:solidFill>
-              <a:prstDash val="solid"/>
-              <a:round/>
-            </a:ln>
-          </p:spPr>
-          <p:txBody>
-            <a:bodyPr/>
-            <a:lstStyle/>
-            <a:p/>
-          </p:txBody>
-        </p:sp>
-        <p:sp>
-          <p:nvSpPr>
             <p:cNvPr id="328" name="pt113"/>
             <p:cNvSpPr/>
             <p:nvPr/>
           </p:nvSpPr>
           <p:spPr>
             <a:xfrm>
-              <a:off x="6366391" y="251537"/>
+              <a:off x="6380125" y="251537"/>
               <a:ext cx="90819" cy="90819"/>
             </a:xfrm>
             <a:prstGeom prst="ellipse">
@@ -14520,7 +14520,93 @@
           </p:nvSpPr>
           <p:spPr>
             <a:xfrm>
-              <a:off x="4533398" y="5906831"/>
+              <a:off x="4178337" y="5906831"/>
+              <a:ext cx="1871319" cy="65379"/>
+            </a:xfrm>
+            <a:prstGeom prst="rect">
+              <a:avLst/>
+            </a:prstGeom>
+            <a:noFill/>
+          </p:spPr>
+          <p:txBody>
+            <a:bodyPr lIns="0" rIns="0" tIns="0" bIns="0" anchorCtr="1" anchor="ctr" wrap="none"/>
+            <a:lstStyle/>
+            <a:p>
+              <a:pPr algn="l" marL="0" marR="0" indent="0">
+                <a:spcBef>
+                  <a:spcPts val="0"/>
+                </a:spcBef>
+                <a:spcAft>
+                  <a:spcPts val="0"/>
+                </a:spcAft>
+              </a:pPr>
+              <a:r>
+                <a:rPr sz="720" i="0" b="0">
+                  <a:solidFill>
+                    <a:srgbClr val="164BCE">
+                      <a:alpha val="100000"/>
+                    </a:srgbClr>
+                  </a:solidFill>
+                  <a:latin typeface="Arial"/>
+                  <a:cs typeface="Arial"/>
+                </a:rPr>
+                <a:t>aspartate family amino acid metabolic process</a:t>
+              </a:r>
+            </a:p>
+          </p:txBody>
+        </p:sp>
+        <p:sp>
+          <p:nvSpPr>
+            <p:cNvPr id="332" name="tx117"/>
+            <p:cNvSpPr/>
+            <p:nvPr/>
+          </p:nvSpPr>
+          <p:spPr>
+            <a:xfrm>
+              <a:off x="4091834" y="5791676"/>
+              <a:ext cx="1957821" cy="65379"/>
+            </a:xfrm>
+            <a:prstGeom prst="rect">
+              <a:avLst/>
+            </a:prstGeom>
+            <a:noFill/>
+          </p:spPr>
+          <p:txBody>
+            <a:bodyPr lIns="0" rIns="0" tIns="0" bIns="0" anchorCtr="1" anchor="ctr" wrap="none"/>
+            <a:lstStyle/>
+            <a:p>
+              <a:pPr algn="l" marL="0" marR="0" indent="0">
+                <a:spcBef>
+                  <a:spcPts val="0"/>
+                </a:spcBef>
+                <a:spcAft>
+                  <a:spcPts val="0"/>
+                </a:spcAft>
+              </a:pPr>
+              <a:r>
+                <a:rPr sz="720" i="0" b="0">
+                  <a:solidFill>
+                    <a:srgbClr val="164BCE">
+                      <a:alpha val="100000"/>
+                    </a:srgbClr>
+                  </a:solidFill>
+                  <a:latin typeface="Arial"/>
+                  <a:cs typeface="Arial"/>
+                </a:rPr>
+                <a:t>non-proteinogenic amino acid metabolic process</a:t>
+              </a:r>
+            </a:p>
+          </p:txBody>
+        </p:sp>
+        <p:sp>
+          <p:nvSpPr>
+            <p:cNvPr id="333" name="tx118"/>
+            <p:cNvSpPr/>
+            <p:nvPr/>
+          </p:nvSpPr>
+          <p:spPr>
+            <a:xfrm>
+              <a:off x="4533398" y="5676522"/>
               <a:ext cx="1516258" cy="65379"/>
             </a:xfrm>
             <a:prstGeom prst="rect">
@@ -14557,13 +14643,56 @@
         </p:sp>
         <p:sp>
           <p:nvSpPr>
-            <p:cNvPr id="332" name="tx117"/>
-            <p:cNvSpPr/>
-            <p:nvPr/>
-          </p:nvSpPr>
-          <p:spPr>
-            <a:xfrm>
-              <a:off x="4979534" y="5791676"/>
+            <p:cNvPr id="334" name="tx119"/>
+            <p:cNvSpPr/>
+            <p:nvPr/>
+          </p:nvSpPr>
+          <p:spPr>
+            <a:xfrm>
+              <a:off x="4507612" y="5561367"/>
+              <a:ext cx="1542044" cy="65379"/>
+            </a:xfrm>
+            <a:prstGeom prst="rect">
+              <a:avLst/>
+            </a:prstGeom>
+            <a:noFill/>
+          </p:spPr>
+          <p:txBody>
+            <a:bodyPr lIns="0" rIns="0" tIns="0" bIns="0" anchorCtr="1" anchor="ctr" wrap="none"/>
+            <a:lstStyle/>
+            <a:p>
+              <a:pPr algn="l" marL="0" marR="0" indent="0">
+                <a:spcBef>
+                  <a:spcPts val="0"/>
+                </a:spcBef>
+                <a:spcAft>
+                  <a:spcPts val="0"/>
+                </a:spcAft>
+              </a:pPr>
+              <a:r>
+                <a:rPr sz="720" i="0" b="0">
+                  <a:solidFill>
+                    <a:srgbClr val="111111">
+                      <a:alpha val="100000"/>
+                    </a:srgbClr>
+                  </a:solidFill>
+                  <a:latin typeface="Arial"/>
+                  <a:cs typeface="Arial"/>
+                </a:rPr>
+                <a:t>ribonucleoprotein complex localization</a:t>
+              </a:r>
+            </a:p>
+          </p:txBody>
+        </p:sp>
+        <p:sp>
+          <p:nvSpPr>
+            <p:cNvPr id="335" name="tx120"/>
+            <p:cNvSpPr/>
+            <p:nvPr/>
+          </p:nvSpPr>
+          <p:spPr>
+            <a:xfrm>
+              <a:off x="4979534" y="5446213"/>
               <a:ext cx="1070122" cy="65379"/>
             </a:xfrm>
             <a:prstGeom prst="rect">
@@ -14600,142 +14729,13 @@
         </p:sp>
         <p:sp>
           <p:nvSpPr>
-            <p:cNvPr id="333" name="tx118"/>
-            <p:cNvSpPr/>
-            <p:nvPr/>
-          </p:nvSpPr>
-          <p:spPr>
-            <a:xfrm>
-              <a:off x="4507612" y="5676522"/>
-              <a:ext cx="1542044" cy="65379"/>
-            </a:xfrm>
-            <a:prstGeom prst="rect">
-              <a:avLst/>
-            </a:prstGeom>
-            <a:noFill/>
-          </p:spPr>
-          <p:txBody>
-            <a:bodyPr lIns="0" rIns="0" tIns="0" bIns="0" anchorCtr="1" anchor="ctr" wrap="none"/>
-            <a:lstStyle/>
-            <a:p>
-              <a:pPr algn="l" marL="0" marR="0" indent="0">
-                <a:spcBef>
-                  <a:spcPts val="0"/>
-                </a:spcBef>
-                <a:spcAft>
-                  <a:spcPts val="0"/>
-                </a:spcAft>
-              </a:pPr>
-              <a:r>
-                <a:rPr sz="720" i="0" b="0">
-                  <a:solidFill>
-                    <a:srgbClr val="111111">
-                      <a:alpha val="100000"/>
-                    </a:srgbClr>
-                  </a:solidFill>
-                  <a:latin typeface="Arial"/>
-                  <a:cs typeface="Arial"/>
-                </a:rPr>
-                <a:t>ribonucleoprotein complex localization</a:t>
-              </a:r>
-            </a:p>
-          </p:txBody>
-        </p:sp>
-        <p:sp>
-          <p:nvSpPr>
-            <p:cNvPr id="334" name="tx119"/>
-            <p:cNvSpPr/>
-            <p:nvPr/>
-          </p:nvSpPr>
-          <p:spPr>
-            <a:xfrm>
-              <a:off x="4092017" y="5511990"/>
-              <a:ext cx="1957638" cy="65379"/>
-            </a:xfrm>
-            <a:prstGeom prst="rect">
-              <a:avLst/>
-            </a:prstGeom>
-            <a:noFill/>
-          </p:spPr>
-          <p:txBody>
-            <a:bodyPr lIns="0" rIns="0" tIns="0" bIns="0" anchorCtr="1" anchor="ctr" wrap="none"/>
-            <a:lstStyle/>
-            <a:p>
-              <a:pPr algn="l" marL="0" marR="0" indent="0">
-                <a:spcBef>
-                  <a:spcPts val="0"/>
-                </a:spcBef>
-                <a:spcAft>
-                  <a:spcPts val="0"/>
-                </a:spcAft>
-              </a:pPr>
-              <a:r>
-                <a:rPr sz="720" i="0" b="0">
-                  <a:solidFill>
-                    <a:srgbClr val="111111">
-                      <a:alpha val="100000"/>
-                    </a:srgbClr>
-                  </a:solidFill>
-                  <a:latin typeface="Arial"/>
-                  <a:cs typeface="Arial"/>
-                </a:rPr>
-                <a:t>endoplasmic reticulum to Golgi vesicle-mediated</a:t>
-              </a:r>
-            </a:p>
-          </p:txBody>
-        </p:sp>
-        <p:sp>
-          <p:nvSpPr>
-            <p:cNvPr id="335" name="tx120"/>
-            <p:cNvSpPr/>
-            <p:nvPr/>
-          </p:nvSpPr>
-          <p:spPr>
-            <a:xfrm>
-              <a:off x="5689657" y="5610745"/>
-              <a:ext cx="359999" cy="65379"/>
-            </a:xfrm>
-            <a:prstGeom prst="rect">
-              <a:avLst/>
-            </a:prstGeom>
-            <a:noFill/>
-          </p:spPr>
-          <p:txBody>
-            <a:bodyPr lIns="0" rIns="0" tIns="0" bIns="0" anchorCtr="1" anchor="ctr" wrap="none"/>
-            <a:lstStyle/>
-            <a:p>
-              <a:pPr algn="l" marL="0" marR="0" indent="0">
-                <a:spcBef>
-                  <a:spcPts val="0"/>
-                </a:spcBef>
-                <a:spcAft>
-                  <a:spcPts val="0"/>
-                </a:spcAft>
-              </a:pPr>
-              <a:r>
-                <a:rPr sz="720" i="0" b="0">
-                  <a:solidFill>
-                    <a:srgbClr val="111111">
-                      <a:alpha val="100000"/>
-                    </a:srgbClr>
-                  </a:solidFill>
-                  <a:latin typeface="Arial"/>
-                  <a:cs typeface="Arial"/>
-                </a:rPr>
-                <a:t>transport</a:t>
-              </a:r>
-            </a:p>
-          </p:txBody>
-        </p:sp>
-        <p:sp>
-          <p:nvSpPr>
             <p:cNvPr id="336" name="tx121"/>
             <p:cNvSpPr/>
             <p:nvPr/>
           </p:nvSpPr>
           <p:spPr>
             <a:xfrm>
-              <a:off x="4918726" y="5446213"/>
+              <a:off x="4918726" y="5331058"/>
               <a:ext cx="1130929" cy="65379"/>
             </a:xfrm>
             <a:prstGeom prst="rect">
@@ -14778,7 +14778,7 @@
           </p:nvSpPr>
           <p:spPr>
             <a:xfrm>
-              <a:off x="4721124" y="5331058"/>
+              <a:off x="4721124" y="5215903"/>
               <a:ext cx="1328531" cy="65379"/>
             </a:xfrm>
             <a:prstGeom prst="rect">
@@ -14821,7 +14821,7 @@
           </p:nvSpPr>
           <p:spPr>
             <a:xfrm>
-              <a:off x="5430790" y="5215903"/>
+              <a:off x="5430790" y="5100749"/>
               <a:ext cx="618865" cy="65379"/>
             </a:xfrm>
             <a:prstGeom prst="rect">
@@ -14864,7 +14864,7 @@
           </p:nvSpPr>
           <p:spPr>
             <a:xfrm>
-              <a:off x="4908394" y="5100749"/>
+              <a:off x="4908394" y="4985594"/>
               <a:ext cx="1141262" cy="65379"/>
             </a:xfrm>
             <a:prstGeom prst="rect">
@@ -14907,7 +14907,7 @@
           </p:nvSpPr>
           <p:spPr>
             <a:xfrm>
-              <a:off x="4847677" y="4985594"/>
+              <a:off x="4847677" y="4870440"/>
               <a:ext cx="1201978" cy="65379"/>
             </a:xfrm>
             <a:prstGeom prst="rect">
@@ -14950,7 +14950,7 @@
           </p:nvSpPr>
           <p:spPr>
             <a:xfrm>
-              <a:off x="4279744" y="4821062"/>
+              <a:off x="4279744" y="4705908"/>
               <a:ext cx="1769912" cy="65379"/>
             </a:xfrm>
             <a:prstGeom prst="rect">
@@ -14993,7 +14993,7 @@
           </p:nvSpPr>
           <p:spPr>
             <a:xfrm>
-              <a:off x="5714986" y="4919817"/>
+              <a:off x="5714986" y="4804663"/>
               <a:ext cx="334670" cy="65379"/>
             </a:xfrm>
             <a:prstGeom prst="rect">
@@ -15036,49 +15036,6 @@
           </p:nvSpPr>
           <p:spPr>
             <a:xfrm>
-              <a:off x="5299208" y="4755285"/>
-              <a:ext cx="750448" cy="65379"/>
-            </a:xfrm>
-            <a:prstGeom prst="rect">
-              <a:avLst/>
-            </a:prstGeom>
-            <a:noFill/>
-          </p:spPr>
-          <p:txBody>
-            <a:bodyPr lIns="0" rIns="0" tIns="0" bIns="0" anchorCtr="1" anchor="ctr" wrap="none"/>
-            <a:lstStyle/>
-            <a:p>
-              <a:pPr algn="l" marL="0" marR="0" indent="0">
-                <a:spcBef>
-                  <a:spcPts val="0"/>
-                </a:spcBef>
-                <a:spcAft>
-                  <a:spcPts val="0"/>
-                </a:spcAft>
-              </a:pPr>
-              <a:r>
-                <a:rPr sz="720" i="0" b="0">
-                  <a:solidFill>
-                    <a:srgbClr val="164BCE">
-                      <a:alpha val="100000"/>
-                    </a:srgbClr>
-                  </a:solidFill>
-                  <a:latin typeface="Arial"/>
-                  <a:cs typeface="Arial"/>
-                </a:rPr>
-                <a:t>fatty acid transport</a:t>
-              </a:r>
-            </a:p>
-          </p:txBody>
-        </p:sp>
-        <p:sp>
-          <p:nvSpPr>
-            <p:cNvPr id="344" name="tx129"/>
-            <p:cNvSpPr/>
-            <p:nvPr/>
-          </p:nvSpPr>
-          <p:spPr>
-            <a:xfrm>
               <a:off x="5288784" y="4640131"/>
               <a:ext cx="760872" cy="65379"/>
             </a:xfrm>
@@ -15116,14 +15073,14 @@
         </p:sp>
         <p:sp>
           <p:nvSpPr>
-            <p:cNvPr id="345" name="tx130"/>
-            <p:cNvSpPr/>
-            <p:nvPr/>
-          </p:nvSpPr>
-          <p:spPr>
-            <a:xfrm>
-              <a:off x="4756420" y="4524976"/>
-              <a:ext cx="1293235" cy="65379"/>
+            <p:cNvPr id="344" name="tx129"/>
+            <p:cNvSpPr/>
+            <p:nvPr/>
+          </p:nvSpPr>
+          <p:spPr>
+            <a:xfrm>
+              <a:off x="4720850" y="4524976"/>
+              <a:ext cx="1328806" cy="65379"/>
             </a:xfrm>
             <a:prstGeom prst="rect">
               <a:avLst/>
@@ -15152,20 +15109,106 @@
                   <a:latin typeface="Arial"/>
                   <a:cs typeface="Arial"/>
                 </a:rPr>
-                <a:t>carbohydrate metabolic process</a:t>
+                <a:t>carboxylic acid catabolic process</a:t>
               </a:r>
             </a:p>
           </p:txBody>
         </p:sp>
         <p:sp>
           <p:nvSpPr>
+            <p:cNvPr id="345" name="tx130"/>
+            <p:cNvSpPr/>
+            <p:nvPr/>
+          </p:nvSpPr>
+          <p:spPr>
+            <a:xfrm>
+              <a:off x="4502674" y="4409822"/>
+              <a:ext cx="1546981" cy="65379"/>
+            </a:xfrm>
+            <a:prstGeom prst="rect">
+              <a:avLst/>
+            </a:prstGeom>
+            <a:noFill/>
+          </p:spPr>
+          <p:txBody>
+            <a:bodyPr lIns="0" rIns="0" tIns="0" bIns="0" anchorCtr="1" anchor="ctr" wrap="none"/>
+            <a:lstStyle/>
+            <a:p>
+              <a:pPr algn="l" marL="0" marR="0" indent="0">
+                <a:spcBef>
+                  <a:spcPts val="0"/>
+                </a:spcBef>
+                <a:spcAft>
+                  <a:spcPts val="0"/>
+                </a:spcAft>
+              </a:pPr>
+              <a:r>
+                <a:rPr sz="720" i="0" b="0">
+                  <a:solidFill>
+                    <a:srgbClr val="164BCE">
+                      <a:alpha val="100000"/>
+                    </a:srgbClr>
+                  </a:solidFill>
+                  <a:latin typeface="Arial"/>
+                  <a:cs typeface="Arial"/>
+                </a:rPr>
+                <a:t>alpha-amino acid biosynthetic process</a:t>
+              </a:r>
+            </a:p>
+          </p:txBody>
+        </p:sp>
+        <p:sp>
+          <p:nvSpPr>
             <p:cNvPr id="346" name="tx131"/>
             <p:cNvSpPr/>
             <p:nvPr/>
           </p:nvSpPr>
           <p:spPr>
             <a:xfrm>
-              <a:off x="4832498" y="4409822"/>
+              <a:off x="5233006" y="4294667"/>
+              <a:ext cx="816650" cy="65379"/>
+            </a:xfrm>
+            <a:prstGeom prst="rect">
+              <a:avLst/>
+            </a:prstGeom>
+            <a:noFill/>
+          </p:spPr>
+          <p:txBody>
+            <a:bodyPr lIns="0" rIns="0" tIns="0" bIns="0" anchorCtr="1" anchor="ctr" wrap="none"/>
+            <a:lstStyle/>
+            <a:p>
+              <a:pPr algn="l" marL="0" marR="0" indent="0">
+                <a:spcBef>
+                  <a:spcPts val="0"/>
+                </a:spcBef>
+                <a:spcAft>
+                  <a:spcPts val="0"/>
+                </a:spcAft>
+              </a:pPr>
+              <a:r>
+                <a:rPr sz="720" i="0" b="0">
+                  <a:solidFill>
+                    <a:srgbClr val="159230">
+                      <a:alpha val="100000"/>
+                    </a:srgbClr>
+                  </a:solidFill>
+                  <a:latin typeface="Arial"/>
+                  <a:cs typeface="Arial"/>
+                </a:rPr>
+                <a:t>response to hypoxia</a:t>
+              </a:r>
+            </a:p>
+          </p:txBody>
+        </p:sp>
+        <p:sp>
+          <p:nvSpPr>
+            <p:cNvPr id="347" name="tx132"/>
+            <p:cNvSpPr/>
+            <p:nvPr/>
+          </p:nvSpPr>
+          <p:spPr>
+            <a:xfrm>
+              <a:off x="4832498" y="4179512"/>
               <a:ext cx="1217157" cy="65379"/>
             </a:xfrm>
             <a:prstGeom prst="rect">
@@ -15202,14 +15245,14 @@
         </p:sp>
         <p:sp>
           <p:nvSpPr>
-            <p:cNvPr id="347" name="tx132"/>
-            <p:cNvSpPr/>
-            <p:nvPr/>
-          </p:nvSpPr>
-          <p:spPr>
-            <a:xfrm>
-              <a:off x="4502674" y="4294667"/>
-              <a:ext cx="1546981" cy="65379"/>
+            <p:cNvPr id="348" name="tx133"/>
+            <p:cNvSpPr/>
+            <p:nvPr/>
+          </p:nvSpPr>
+          <p:spPr>
+            <a:xfrm>
+              <a:off x="4482283" y="4064358"/>
+              <a:ext cx="1567373" cy="65379"/>
             </a:xfrm>
             <a:prstGeom prst="rect">
               <a:avLst/>
@@ -15231,70 +15274,27 @@
               <a:r>
                 <a:rPr sz="720" i="0" b="0">
                   <a:solidFill>
-                    <a:srgbClr val="164BCE">
+                    <a:srgbClr val="111111">
                       <a:alpha val="100000"/>
                     </a:srgbClr>
                   </a:solidFill>
                   <a:latin typeface="Arial"/>
                   <a:cs typeface="Arial"/>
                 </a:rPr>
-                <a:t>alpha-amino acid biosynthetic process</a:t>
+                <a:t>protein-containing complex localization</a:t>
               </a:r>
             </a:p>
           </p:txBody>
         </p:sp>
         <p:sp>
           <p:nvSpPr>
-            <p:cNvPr id="348" name="tx133"/>
-            <p:cNvSpPr/>
-            <p:nvPr/>
-          </p:nvSpPr>
-          <p:spPr>
-            <a:xfrm>
-              <a:off x="5233006" y="4179512"/>
-              <a:ext cx="816650" cy="65379"/>
-            </a:xfrm>
-            <a:prstGeom prst="rect">
-              <a:avLst/>
-            </a:prstGeom>
-            <a:noFill/>
-          </p:spPr>
-          <p:txBody>
-            <a:bodyPr lIns="0" rIns="0" tIns="0" bIns="0" anchorCtr="1" anchor="ctr" wrap="none"/>
-            <a:lstStyle/>
-            <a:p>
-              <a:pPr algn="l" marL="0" marR="0" indent="0">
-                <a:spcBef>
-                  <a:spcPts val="0"/>
-                </a:spcBef>
-                <a:spcAft>
-                  <a:spcPts val="0"/>
-                </a:spcAft>
-              </a:pPr>
-              <a:r>
-                <a:rPr sz="720" i="0" b="0">
-                  <a:solidFill>
-                    <a:srgbClr val="159230">
-                      <a:alpha val="100000"/>
-                    </a:srgbClr>
-                  </a:solidFill>
-                  <a:latin typeface="Arial"/>
-                  <a:cs typeface="Arial"/>
-                </a:rPr>
-                <a:t>response to hypoxia</a:t>
-              </a:r>
-            </a:p>
-          </p:txBody>
-        </p:sp>
-        <p:sp>
-          <p:nvSpPr>
             <p:cNvPr id="349" name="tx134"/>
             <p:cNvSpPr/>
             <p:nvPr/>
           </p:nvSpPr>
           <p:spPr>
             <a:xfrm>
-              <a:off x="4446896" y="4064358"/>
+              <a:off x="4446896" y="3949203"/>
               <a:ext cx="1602760" cy="65379"/>
             </a:xfrm>
             <a:prstGeom prst="rect">
@@ -15337,49 +15337,6 @@
           </p:nvSpPr>
           <p:spPr>
             <a:xfrm>
-              <a:off x="4482283" y="3949203"/>
-              <a:ext cx="1567373" cy="65379"/>
-            </a:xfrm>
-            <a:prstGeom prst="rect">
-              <a:avLst/>
-            </a:prstGeom>
-            <a:noFill/>
-          </p:spPr>
-          <p:txBody>
-            <a:bodyPr lIns="0" rIns="0" tIns="0" bIns="0" anchorCtr="1" anchor="ctr" wrap="none"/>
-            <a:lstStyle/>
-            <a:p>
-              <a:pPr algn="l" marL="0" marR="0" indent="0">
-                <a:spcBef>
-                  <a:spcPts val="0"/>
-                </a:spcBef>
-                <a:spcAft>
-                  <a:spcPts val="0"/>
-                </a:spcAft>
-              </a:pPr>
-              <a:r>
-                <a:rPr sz="720" i="0" b="0">
-                  <a:solidFill>
-                    <a:srgbClr val="111111">
-                      <a:alpha val="100000"/>
-                    </a:srgbClr>
-                  </a:solidFill>
-                  <a:latin typeface="Arial"/>
-                  <a:cs typeface="Arial"/>
-                </a:rPr>
-                <a:t>protein-containing complex localization</a:t>
-              </a:r>
-            </a:p>
-          </p:txBody>
-        </p:sp>
-        <p:sp>
-          <p:nvSpPr>
-            <p:cNvPr id="351" name="tx136"/>
-            <p:cNvSpPr/>
-            <p:nvPr/>
-          </p:nvSpPr>
-          <p:spPr>
-            <a:xfrm>
               <a:off x="5263455" y="3834049"/>
               <a:ext cx="786201" cy="65379"/>
             </a:xfrm>
@@ -15417,7 +15374,7 @@
         </p:sp>
         <p:sp>
           <p:nvSpPr>
-            <p:cNvPr id="352" name="tx137"/>
+            <p:cNvPr id="351" name="tx136"/>
             <p:cNvSpPr/>
             <p:nvPr/>
           </p:nvSpPr>
@@ -15460,7 +15417,7 @@
         </p:sp>
         <p:sp>
           <p:nvSpPr>
-            <p:cNvPr id="353" name="tx138"/>
+            <p:cNvPr id="352" name="tx137"/>
             <p:cNvSpPr/>
             <p:nvPr/>
           </p:nvSpPr>
@@ -15503,7 +15460,7 @@
         </p:sp>
         <p:sp>
           <p:nvSpPr>
-            <p:cNvPr id="354" name="tx139"/>
+            <p:cNvPr id="353" name="tx138"/>
             <p:cNvSpPr/>
             <p:nvPr/>
           </p:nvSpPr>
@@ -15546,7 +15503,7 @@
         </p:sp>
         <p:sp>
           <p:nvSpPr>
-            <p:cNvPr id="355" name="tx140"/>
+            <p:cNvPr id="354" name="tx139"/>
             <p:cNvSpPr/>
             <p:nvPr/>
           </p:nvSpPr>
@@ -15589,7 +15546,7 @@
         </p:sp>
         <p:sp>
           <p:nvSpPr>
-            <p:cNvPr id="356" name="tx141"/>
+            <p:cNvPr id="355" name="tx140"/>
             <p:cNvSpPr/>
             <p:nvPr/>
           </p:nvSpPr>
@@ -15632,13 +15589,56 @@
         </p:sp>
         <p:sp>
           <p:nvSpPr>
+            <p:cNvPr id="356" name="tx141"/>
+            <p:cNvSpPr/>
+            <p:nvPr/>
+          </p:nvSpPr>
+          <p:spPr>
+            <a:xfrm>
+              <a:off x="4310193" y="3143121"/>
+              <a:ext cx="1739463" cy="65379"/>
+            </a:xfrm>
+            <a:prstGeom prst="rect">
+              <a:avLst/>
+            </a:prstGeom>
+            <a:noFill/>
+          </p:spPr>
+          <p:txBody>
+            <a:bodyPr lIns="0" rIns="0" tIns="0" bIns="0" anchorCtr="1" anchor="ctr" wrap="none"/>
+            <a:lstStyle/>
+            <a:p>
+              <a:pPr algn="l" marL="0" marR="0" indent="0">
+                <a:spcBef>
+                  <a:spcPts val="0"/>
+                </a:spcBef>
+                <a:spcAft>
+                  <a:spcPts val="0"/>
+                </a:spcAft>
+              </a:pPr>
+              <a:r>
+                <a:rPr sz="720" i="0" b="0">
+                  <a:solidFill>
+                    <a:srgbClr val="164BCE">
+                      <a:alpha val="100000"/>
+                    </a:srgbClr>
+                  </a:solidFill>
+                  <a:latin typeface="Arial"/>
+                  <a:cs typeface="Arial"/>
+                </a:rPr>
+                <a:t>serine family amino acid metabolic process</a:t>
+              </a:r>
+            </a:p>
+          </p:txBody>
+        </p:sp>
+        <p:sp>
+          <p:nvSpPr>
             <p:cNvPr id="357" name="tx142"/>
             <p:cNvSpPr/>
             <p:nvPr/>
           </p:nvSpPr>
           <p:spPr>
             <a:xfrm>
-              <a:off x="4599143" y="3143121"/>
+              <a:off x="4599143" y="3027967"/>
               <a:ext cx="1450512" cy="65379"/>
             </a:xfrm>
             <a:prstGeom prst="rect">
@@ -15681,49 +15681,6 @@
           </p:nvSpPr>
           <p:spPr>
             <a:xfrm>
-              <a:off x="4310193" y="3027967"/>
-              <a:ext cx="1739463" cy="65379"/>
-            </a:xfrm>
-            <a:prstGeom prst="rect">
-              <a:avLst/>
-            </a:prstGeom>
-            <a:noFill/>
-          </p:spPr>
-          <p:txBody>
-            <a:bodyPr lIns="0" rIns="0" tIns="0" bIns="0" anchorCtr="1" anchor="ctr" wrap="none"/>
-            <a:lstStyle/>
-            <a:p>
-              <a:pPr algn="l" marL="0" marR="0" indent="0">
-                <a:spcBef>
-                  <a:spcPts val="0"/>
-                </a:spcBef>
-                <a:spcAft>
-                  <a:spcPts val="0"/>
-                </a:spcAft>
-              </a:pPr>
-              <a:r>
-                <a:rPr sz="720" i="0" b="0">
-                  <a:solidFill>
-                    <a:srgbClr val="164BCE">
-                      <a:alpha val="100000"/>
-                    </a:srgbClr>
-                  </a:solidFill>
-                  <a:latin typeface="Arial"/>
-                  <a:cs typeface="Arial"/>
-                </a:rPr>
-                <a:t>serine family amino acid metabolic process</a:t>
-              </a:r>
-            </a:p>
-          </p:txBody>
-        </p:sp>
-        <p:sp>
-          <p:nvSpPr>
-            <p:cNvPr id="359" name="tx144"/>
-            <p:cNvSpPr/>
-            <p:nvPr/>
-          </p:nvSpPr>
-          <p:spPr>
-            <a:xfrm>
               <a:off x="4462258" y="2912812"/>
               <a:ext cx="1587398" cy="65379"/>
             </a:xfrm>
@@ -15761,7 +15718,7 @@
         </p:sp>
         <p:sp>
           <p:nvSpPr>
-            <p:cNvPr id="360" name="tx145"/>
+            <p:cNvPr id="359" name="tx144"/>
             <p:cNvSpPr/>
             <p:nvPr/>
           </p:nvSpPr>
@@ -15804,7 +15761,7 @@
         </p:sp>
         <p:sp>
           <p:nvSpPr>
-            <p:cNvPr id="361" name="tx146"/>
+            <p:cNvPr id="360" name="tx145"/>
             <p:cNvSpPr/>
             <p:nvPr/>
           </p:nvSpPr>
@@ -15847,7 +15804,7 @@
         </p:sp>
         <p:sp>
           <p:nvSpPr>
-            <p:cNvPr id="362" name="tx147"/>
+            <p:cNvPr id="361" name="tx146"/>
             <p:cNvSpPr/>
             <p:nvPr/>
           </p:nvSpPr>
@@ -15890,13 +15847,99 @@
         </p:sp>
         <p:sp>
           <p:nvSpPr>
+            <p:cNvPr id="362" name="tx147"/>
+            <p:cNvSpPr/>
+            <p:nvPr/>
+          </p:nvSpPr>
+          <p:spPr>
+            <a:xfrm>
+              <a:off x="4796928" y="2567348"/>
+              <a:ext cx="1252728" cy="65379"/>
+            </a:xfrm>
+            <a:prstGeom prst="rect">
+              <a:avLst/>
+            </a:prstGeom>
+            <a:noFill/>
+          </p:spPr>
+          <p:txBody>
+            <a:bodyPr lIns="0" rIns="0" tIns="0" bIns="0" anchorCtr="1" anchor="ctr" wrap="none"/>
+            <a:lstStyle/>
+            <a:p>
+              <a:pPr algn="l" marL="0" marR="0" indent="0">
+                <a:spcBef>
+                  <a:spcPts val="0"/>
+                </a:spcBef>
+                <a:spcAft>
+                  <a:spcPts val="0"/>
+                </a:spcAft>
+              </a:pPr>
+              <a:r>
+                <a:rPr sz="720" i="0" b="0">
+                  <a:solidFill>
+                    <a:srgbClr val="111111">
+                      <a:alpha val="100000"/>
+                    </a:srgbClr>
+                  </a:solidFill>
+                  <a:latin typeface="Arial"/>
+                  <a:cs typeface="Arial"/>
+                </a:rPr>
+                <a:t>glycoprotein metabolic process</a:t>
+              </a:r>
+            </a:p>
+          </p:txBody>
+        </p:sp>
+        <p:sp>
+          <p:nvSpPr>
             <p:cNvPr id="363" name="tx148"/>
             <p:cNvSpPr/>
             <p:nvPr/>
           </p:nvSpPr>
           <p:spPr>
             <a:xfrm>
-              <a:off x="4304798" y="2567348"/>
+              <a:off x="5096211" y="2452194"/>
+              <a:ext cx="953444" cy="65379"/>
+            </a:xfrm>
+            <a:prstGeom prst="rect">
+              <a:avLst/>
+            </a:prstGeom>
+            <a:noFill/>
+          </p:spPr>
+          <p:txBody>
+            <a:bodyPr lIns="0" rIns="0" tIns="0" bIns="0" anchorCtr="1" anchor="ctr" wrap="none"/>
+            <a:lstStyle/>
+            <a:p>
+              <a:pPr algn="l" marL="0" marR="0" indent="0">
+                <a:spcBef>
+                  <a:spcPts val="0"/>
+                </a:spcBef>
+                <a:spcAft>
+                  <a:spcPts val="0"/>
+                </a:spcAft>
+              </a:pPr>
+              <a:r>
+                <a:rPr sz="720" i="0" b="0">
+                  <a:solidFill>
+                    <a:srgbClr val="164BCE">
+                      <a:alpha val="100000"/>
+                    </a:srgbClr>
+                  </a:solidFill>
+                  <a:latin typeface="Arial"/>
+                  <a:cs typeface="Arial"/>
+                </a:rPr>
+                <a:t>NAD metabolic process</a:t>
+              </a:r>
+            </a:p>
+          </p:txBody>
+        </p:sp>
+        <p:sp>
+          <p:nvSpPr>
+            <p:cNvPr id="364" name="tx149"/>
+            <p:cNvSpPr/>
+            <p:nvPr/>
+          </p:nvSpPr>
+          <p:spPr>
+            <a:xfrm>
+              <a:off x="4304798" y="2337039"/>
               <a:ext cx="1744858" cy="65379"/>
             </a:xfrm>
             <a:prstGeom prst="rect">
@@ -15933,93 +15976,7 @@
         </p:sp>
         <p:sp>
           <p:nvSpPr>
-            <p:cNvPr id="364" name="tx149"/>
-            <p:cNvSpPr/>
-            <p:nvPr/>
-          </p:nvSpPr>
-          <p:spPr>
-            <a:xfrm>
-              <a:off x="4796928" y="2452194"/>
-              <a:ext cx="1252728" cy="65379"/>
-            </a:xfrm>
-            <a:prstGeom prst="rect">
-              <a:avLst/>
-            </a:prstGeom>
-            <a:noFill/>
-          </p:spPr>
-          <p:txBody>
-            <a:bodyPr lIns="0" rIns="0" tIns="0" bIns="0" anchorCtr="1" anchor="ctr" wrap="none"/>
-            <a:lstStyle/>
-            <a:p>
-              <a:pPr algn="l" marL="0" marR="0" indent="0">
-                <a:spcBef>
-                  <a:spcPts val="0"/>
-                </a:spcBef>
-                <a:spcAft>
-                  <a:spcPts val="0"/>
-                </a:spcAft>
-              </a:pPr>
-              <a:r>
-                <a:rPr sz="720" i="0" b="0">
-                  <a:solidFill>
-                    <a:srgbClr val="111111">
-                      <a:alpha val="100000"/>
-                    </a:srgbClr>
-                  </a:solidFill>
-                  <a:latin typeface="Arial"/>
-                  <a:cs typeface="Arial"/>
-                </a:rPr>
-                <a:t>glycoprotein metabolic process</a:t>
-              </a:r>
-            </a:p>
-          </p:txBody>
-        </p:sp>
-        <p:sp>
-          <p:nvSpPr>
             <p:cNvPr id="365" name="tx150"/>
-            <p:cNvSpPr/>
-            <p:nvPr/>
-          </p:nvSpPr>
-          <p:spPr>
-            <a:xfrm>
-              <a:off x="5096211" y="2337039"/>
-              <a:ext cx="953444" cy="65379"/>
-            </a:xfrm>
-            <a:prstGeom prst="rect">
-              <a:avLst/>
-            </a:prstGeom>
-            <a:noFill/>
-          </p:spPr>
-          <p:txBody>
-            <a:bodyPr lIns="0" rIns="0" tIns="0" bIns="0" anchorCtr="1" anchor="ctr" wrap="none"/>
-            <a:lstStyle/>
-            <a:p>
-              <a:pPr algn="l" marL="0" marR="0" indent="0">
-                <a:spcBef>
-                  <a:spcPts val="0"/>
-                </a:spcBef>
-                <a:spcAft>
-                  <a:spcPts val="0"/>
-                </a:spcAft>
-              </a:pPr>
-              <a:r>
-                <a:rPr sz="720" i="0" b="0">
-                  <a:solidFill>
-                    <a:srgbClr val="164BCE">
-                      <a:alpha val="100000"/>
-                    </a:srgbClr>
-                  </a:solidFill>
-                  <a:latin typeface="Arial"/>
-                  <a:cs typeface="Arial"/>
-                </a:rPr>
-                <a:t>NAD metabolic process</a:t>
-              </a:r>
-            </a:p>
-          </p:txBody>
-        </p:sp>
-        <p:sp>
-          <p:nvSpPr>
-            <p:cNvPr id="366" name="tx151"/>
             <p:cNvSpPr/>
             <p:nvPr/>
           </p:nvSpPr>
@@ -16062,13 +16019,142 @@
         </p:sp>
         <p:sp>
           <p:nvSpPr>
+            <p:cNvPr id="366" name="tx151"/>
+            <p:cNvSpPr/>
+            <p:nvPr/>
+          </p:nvSpPr>
+          <p:spPr>
+            <a:xfrm>
+              <a:off x="4000394" y="2057353"/>
+              <a:ext cx="2049261" cy="65379"/>
+            </a:xfrm>
+            <a:prstGeom prst="rect">
+              <a:avLst/>
+            </a:prstGeom>
+            <a:noFill/>
+          </p:spPr>
+          <p:txBody>
+            <a:bodyPr lIns="0" rIns="0" tIns="0" bIns="0" anchorCtr="1" anchor="ctr" wrap="none"/>
+            <a:lstStyle/>
+            <a:p>
+              <a:pPr algn="l" marL="0" marR="0" indent="0">
+                <a:spcBef>
+                  <a:spcPts val="0"/>
+                </a:spcBef>
+                <a:spcAft>
+                  <a:spcPts val="0"/>
+                </a:spcAft>
+              </a:pPr>
+              <a:r>
+                <a:rPr sz="720" i="0" b="0">
+                  <a:solidFill>
+                    <a:srgbClr val="164BCE">
+                      <a:alpha val="100000"/>
+                    </a:srgbClr>
+                  </a:solidFill>
+                  <a:latin typeface="Arial"/>
+                  <a:cs typeface="Arial"/>
+                </a:rPr>
+                <a:t>nucleobase-containing small molecule biosynthetic</a:t>
+              </a:r>
+            </a:p>
+          </p:txBody>
+        </p:sp>
+        <p:sp>
+          <p:nvSpPr>
             <p:cNvPr id="367" name="tx152"/>
             <p:cNvSpPr/>
             <p:nvPr/>
           </p:nvSpPr>
           <p:spPr>
             <a:xfrm>
-              <a:off x="4477437" y="2106730"/>
+              <a:off x="5730165" y="2156108"/>
+              <a:ext cx="319491" cy="65379"/>
+            </a:xfrm>
+            <a:prstGeom prst="rect">
+              <a:avLst/>
+            </a:prstGeom>
+            <a:noFill/>
+          </p:spPr>
+          <p:txBody>
+            <a:bodyPr lIns="0" rIns="0" tIns="0" bIns="0" anchorCtr="1" anchor="ctr" wrap="none"/>
+            <a:lstStyle/>
+            <a:p>
+              <a:pPr algn="l" marL="0" marR="0" indent="0">
+                <a:spcBef>
+                  <a:spcPts val="0"/>
+                </a:spcBef>
+                <a:spcAft>
+                  <a:spcPts val="0"/>
+                </a:spcAft>
+              </a:pPr>
+              <a:r>
+                <a:rPr sz="720" i="0" b="0">
+                  <a:solidFill>
+                    <a:srgbClr val="164BCE">
+                      <a:alpha val="100000"/>
+                    </a:srgbClr>
+                  </a:solidFill>
+                  <a:latin typeface="Arial"/>
+                  <a:cs typeface="Arial"/>
+                </a:rPr>
+                <a:t>process</a:t>
+              </a:r>
+            </a:p>
+          </p:txBody>
+        </p:sp>
+        <p:sp>
+          <p:nvSpPr>
+            <p:cNvPr id="368" name="tx153"/>
+            <p:cNvSpPr/>
+            <p:nvPr/>
+          </p:nvSpPr>
+          <p:spPr>
+            <a:xfrm>
+              <a:off x="4492616" y="1991576"/>
+              <a:ext cx="1557040" cy="65379"/>
+            </a:xfrm>
+            <a:prstGeom prst="rect">
+              <a:avLst/>
+            </a:prstGeom>
+            <a:noFill/>
+          </p:spPr>
+          <p:txBody>
+            <a:bodyPr lIns="0" rIns="0" tIns="0" bIns="0" anchorCtr="1" anchor="ctr" wrap="none"/>
+            <a:lstStyle/>
+            <a:p>
+              <a:pPr algn="l" marL="0" marR="0" indent="0">
+                <a:spcBef>
+                  <a:spcPts val="0"/>
+                </a:spcBef>
+                <a:spcAft>
+                  <a:spcPts val="0"/>
+                </a:spcAft>
+              </a:pPr>
+              <a:r>
+                <a:rPr sz="720" i="0" b="0">
+                  <a:solidFill>
+                    <a:srgbClr val="164BCE">
+                      <a:alpha val="100000"/>
+                    </a:srgbClr>
+                  </a:solidFill>
+                  <a:latin typeface="Arial"/>
+                  <a:cs typeface="Arial"/>
+                </a:rPr>
+                <a:t>monocarboxylic acid catabolic process</a:t>
+              </a:r>
+            </a:p>
+          </p:txBody>
+        </p:sp>
+        <p:sp>
+          <p:nvSpPr>
+            <p:cNvPr id="369" name="tx154"/>
+            <p:cNvSpPr/>
+            <p:nvPr/>
+          </p:nvSpPr>
+          <p:spPr>
+            <a:xfrm>
+              <a:off x="4477437" y="1876421"/>
               <a:ext cx="1572219" cy="65379"/>
             </a:xfrm>
             <a:prstGeom prst="rect">
@@ -16105,14 +16191,57 @@
         </p:sp>
         <p:sp>
           <p:nvSpPr>
-            <p:cNvPr id="368" name="tx153"/>
-            <p:cNvSpPr/>
-            <p:nvPr/>
-          </p:nvSpPr>
-          <p:spPr>
-            <a:xfrm>
-              <a:off x="4000394" y="1942198"/>
-              <a:ext cx="2049261" cy="65379"/>
+            <p:cNvPr id="370" name="tx155"/>
+            <p:cNvSpPr/>
+            <p:nvPr/>
+          </p:nvSpPr>
+          <p:spPr>
+            <a:xfrm>
+              <a:off x="4832315" y="1761267"/>
+              <a:ext cx="1217340" cy="65379"/>
+            </a:xfrm>
+            <a:prstGeom prst="rect">
+              <a:avLst/>
+            </a:prstGeom>
+            <a:noFill/>
+          </p:spPr>
+          <p:txBody>
+            <a:bodyPr lIns="0" rIns="0" tIns="0" bIns="0" anchorCtr="1" anchor="ctr" wrap="none"/>
+            <a:lstStyle/>
+            <a:p>
+              <a:pPr algn="l" marL="0" marR="0" indent="0">
+                <a:spcBef>
+                  <a:spcPts val="0"/>
+                </a:spcBef>
+                <a:spcAft>
+                  <a:spcPts val="0"/>
+                </a:spcAft>
+              </a:pPr>
+              <a:r>
+                <a:rPr sz="720" i="0" b="0">
+                  <a:solidFill>
+                    <a:srgbClr val="159230">
+                      <a:alpha val="100000"/>
+                    </a:srgbClr>
+                  </a:solidFill>
+                  <a:latin typeface="Arial"/>
+                  <a:cs typeface="Arial"/>
+                </a:rPr>
+                <a:t>determination of adult lifespan</a:t>
+              </a:r>
+            </a:p>
+          </p:txBody>
+        </p:sp>
+        <p:sp>
+          <p:nvSpPr>
+            <p:cNvPr id="371" name="tx156"/>
+            <p:cNvSpPr/>
+            <p:nvPr/>
+          </p:nvSpPr>
+          <p:spPr>
+            <a:xfrm>
+              <a:off x="4822166" y="1646112"/>
+              <a:ext cx="1227490" cy="65379"/>
             </a:xfrm>
             <a:prstGeom prst="rect">
               <a:avLst/>
@@ -16141,20 +16270,321 @@
                   <a:latin typeface="Arial"/>
                   <a:cs typeface="Arial"/>
                 </a:rPr>
-                <a:t>nucleobase-containing small molecule biosynthetic</a:t>
+                <a:t>nucleobase metabolic process</a:t>
               </a:r>
             </a:p>
           </p:txBody>
         </p:sp>
         <p:sp>
           <p:nvSpPr>
-            <p:cNvPr id="369" name="tx154"/>
-            <p:cNvSpPr/>
-            <p:nvPr/>
-          </p:nvSpPr>
-          <p:spPr>
-            <a:xfrm>
-              <a:off x="5730165" y="2040953"/>
+            <p:cNvPr id="372" name="tx157"/>
+            <p:cNvSpPr/>
+            <p:nvPr/>
+          </p:nvSpPr>
+          <p:spPr>
+            <a:xfrm>
+              <a:off x="4487312" y="1530957"/>
+              <a:ext cx="1562343" cy="65379"/>
+            </a:xfrm>
+            <a:prstGeom prst="rect">
+              <a:avLst/>
+            </a:prstGeom>
+            <a:noFill/>
+          </p:spPr>
+          <p:txBody>
+            <a:bodyPr lIns="0" rIns="0" tIns="0" bIns="0" anchorCtr="1" anchor="ctr" wrap="none"/>
+            <a:lstStyle/>
+            <a:p>
+              <a:pPr algn="l" marL="0" marR="0" indent="0">
+                <a:spcBef>
+                  <a:spcPts val="0"/>
+                </a:spcBef>
+                <a:spcAft>
+                  <a:spcPts val="0"/>
+                </a:spcAft>
+              </a:pPr>
+              <a:r>
+                <a:rPr sz="720" i="0" b="0">
+                  <a:solidFill>
+                    <a:srgbClr val="111111">
+                      <a:alpha val="100000"/>
+                    </a:srgbClr>
+                  </a:solidFill>
+                  <a:latin typeface="Arial"/>
+                  <a:cs typeface="Arial"/>
+                </a:rPr>
+                <a:t>organophosphate biosynthetic process</a:t>
+              </a:r>
+            </a:p>
+          </p:txBody>
+        </p:sp>
+        <p:sp>
+          <p:nvSpPr>
+            <p:cNvPr id="373" name="tx158"/>
+            <p:cNvSpPr/>
+            <p:nvPr/>
+          </p:nvSpPr>
+          <p:spPr>
+            <a:xfrm>
+              <a:off x="4918543" y="1415803"/>
+              <a:ext cx="1131112" cy="65379"/>
+            </a:xfrm>
+            <a:prstGeom prst="rect">
+              <a:avLst/>
+            </a:prstGeom>
+            <a:noFill/>
+          </p:spPr>
+          <p:txBody>
+            <a:bodyPr lIns="0" rIns="0" tIns="0" bIns="0" anchorCtr="1" anchor="ctr" wrap="none"/>
+            <a:lstStyle/>
+            <a:p>
+              <a:pPr algn="l" marL="0" marR="0" indent="0">
+                <a:spcBef>
+                  <a:spcPts val="0"/>
+                </a:spcBef>
+                <a:spcAft>
+                  <a:spcPts val="0"/>
+                </a:spcAft>
+              </a:pPr>
+              <a:r>
+                <a:rPr sz="720" i="0" b="0">
+                  <a:solidFill>
+                    <a:srgbClr val="164BCE">
+                      <a:alpha val="100000"/>
+                    </a:srgbClr>
+                  </a:solidFill>
+                  <a:latin typeface="Arial"/>
+                  <a:cs typeface="Arial"/>
+                </a:rPr>
+                <a:t>aldehyde metabolic process</a:t>
+              </a:r>
+            </a:p>
+          </p:txBody>
+        </p:sp>
+        <p:sp>
+          <p:nvSpPr>
+            <p:cNvPr id="374" name="tx159"/>
+            <p:cNvSpPr/>
+            <p:nvPr/>
+          </p:nvSpPr>
+          <p:spPr>
+            <a:xfrm>
+              <a:off x="4249203" y="1300648"/>
+              <a:ext cx="1800453" cy="65379"/>
+            </a:xfrm>
+            <a:prstGeom prst="rect">
+              <a:avLst/>
+            </a:prstGeom>
+            <a:noFill/>
+          </p:spPr>
+          <p:txBody>
+            <a:bodyPr lIns="0" rIns="0" tIns="0" bIns="0" anchorCtr="1" anchor="ctr" wrap="none"/>
+            <a:lstStyle/>
+            <a:p>
+              <a:pPr algn="l" marL="0" marR="0" indent="0">
+                <a:spcBef>
+                  <a:spcPts val="0"/>
+                </a:spcBef>
+                <a:spcAft>
+                  <a:spcPts val="0"/>
+                </a:spcAft>
+              </a:pPr>
+              <a:r>
+                <a:rPr sz="720" i="0" b="0">
+                  <a:solidFill>
+                    <a:srgbClr val="164BCE">
+                      <a:alpha val="100000"/>
+                    </a:srgbClr>
+                  </a:solidFill>
+                  <a:latin typeface="Arial"/>
+                  <a:cs typeface="Arial"/>
+                </a:rPr>
+                <a:t>carbohydrate derivative biosynthetic process</a:t>
+              </a:r>
+            </a:p>
+          </p:txBody>
+        </p:sp>
+        <p:sp>
+          <p:nvSpPr>
+            <p:cNvPr id="375" name="tx160"/>
+            <p:cNvSpPr/>
+            <p:nvPr/>
+          </p:nvSpPr>
+          <p:spPr>
+            <a:xfrm>
+              <a:off x="4796928" y="1185494"/>
+              <a:ext cx="1252728" cy="65379"/>
+            </a:xfrm>
+            <a:prstGeom prst="rect">
+              <a:avLst/>
+            </a:prstGeom>
+            <a:noFill/>
+          </p:spPr>
+          <p:txBody>
+            <a:bodyPr lIns="0" rIns="0" tIns="0" bIns="0" anchorCtr="1" anchor="ctr" wrap="none"/>
+            <a:lstStyle/>
+            <a:p>
+              <a:pPr algn="l" marL="0" marR="0" indent="0">
+                <a:spcBef>
+                  <a:spcPts val="0"/>
+                </a:spcBef>
+                <a:spcAft>
+                  <a:spcPts val="0"/>
+                </a:spcAft>
+              </a:pPr>
+              <a:r>
+                <a:rPr sz="720" i="0" b="0">
+                  <a:solidFill>
+                    <a:srgbClr val="164BCE">
+                      <a:alpha val="100000"/>
+                    </a:srgbClr>
+                  </a:solidFill>
+                  <a:latin typeface="Arial"/>
+                  <a:cs typeface="Arial"/>
+                </a:rPr>
+                <a:t>L-amino acid catabolic process</a:t>
+              </a:r>
+            </a:p>
+          </p:txBody>
+        </p:sp>
+        <p:sp>
+          <p:nvSpPr>
+            <p:cNvPr id="376" name="tx161"/>
+            <p:cNvSpPr/>
+            <p:nvPr/>
+          </p:nvSpPr>
+          <p:spPr>
+            <a:xfrm>
+              <a:off x="4619443" y="1070339"/>
+              <a:ext cx="1430213" cy="65379"/>
+            </a:xfrm>
+            <a:prstGeom prst="rect">
+              <a:avLst/>
+            </a:prstGeom>
+            <a:noFill/>
+          </p:spPr>
+          <p:txBody>
+            <a:bodyPr lIns="0" rIns="0" tIns="0" bIns="0" anchorCtr="1" anchor="ctr" wrap="none"/>
+            <a:lstStyle/>
+            <a:p>
+              <a:pPr algn="l" marL="0" marR="0" indent="0">
+                <a:spcBef>
+                  <a:spcPts val="0"/>
+                </a:spcBef>
+                <a:spcAft>
+                  <a:spcPts val="0"/>
+                </a:spcAft>
+              </a:pPr>
+              <a:r>
+                <a:rPr sz="720" i="0" b="0">
+                  <a:solidFill>
+                    <a:srgbClr val="164BCE">
+                      <a:alpha val="100000"/>
+                    </a:srgbClr>
+                  </a:solidFill>
+                  <a:latin typeface="Arial"/>
+                  <a:cs typeface="Arial"/>
+                </a:rPr>
+                <a:t>dicarboxylic acid metabolic process</a:t>
+              </a:r>
+            </a:p>
+          </p:txBody>
+        </p:sp>
+        <p:sp>
+          <p:nvSpPr>
+            <p:cNvPr id="377" name="tx162"/>
+            <p:cNvSpPr/>
+            <p:nvPr/>
+          </p:nvSpPr>
+          <p:spPr>
+            <a:xfrm>
+              <a:off x="4431900" y="955185"/>
+              <a:ext cx="1617756" cy="65379"/>
+            </a:xfrm>
+            <a:prstGeom prst="rect">
+              <a:avLst/>
+            </a:prstGeom>
+            <a:noFill/>
+          </p:spPr>
+          <p:txBody>
+            <a:bodyPr lIns="0" rIns="0" tIns="0" bIns="0" anchorCtr="1" anchor="ctr" wrap="none"/>
+            <a:lstStyle/>
+            <a:p>
+              <a:pPr algn="l" marL="0" marR="0" indent="0">
+                <a:spcBef>
+                  <a:spcPts val="0"/>
+                </a:spcBef>
+                <a:spcAft>
+                  <a:spcPts val="0"/>
+                </a:spcAft>
+              </a:pPr>
+              <a:r>
+                <a:rPr sz="720" i="0" b="0">
+                  <a:solidFill>
+                    <a:srgbClr val="164BCE">
+                      <a:alpha val="100000"/>
+                    </a:srgbClr>
+                  </a:solidFill>
+                  <a:latin typeface="Arial"/>
+                  <a:cs typeface="Arial"/>
+                </a:rPr>
+                <a:t>water-soluble vitamin metabolic process</a:t>
+              </a:r>
+            </a:p>
+          </p:txBody>
+        </p:sp>
+        <p:sp>
+          <p:nvSpPr>
+            <p:cNvPr id="378" name="tx163"/>
+            <p:cNvSpPr/>
+            <p:nvPr/>
+          </p:nvSpPr>
+          <p:spPr>
+            <a:xfrm>
+              <a:off x="3995182" y="790652"/>
+              <a:ext cx="2054473" cy="65379"/>
+            </a:xfrm>
+            <a:prstGeom prst="rect">
+              <a:avLst/>
+            </a:prstGeom>
+            <a:noFill/>
+          </p:spPr>
+          <p:txBody>
+            <a:bodyPr lIns="0" rIns="0" tIns="0" bIns="0" anchorCtr="1" anchor="ctr" wrap="none"/>
+            <a:lstStyle/>
+            <a:p>
+              <a:pPr algn="l" marL="0" marR="0" indent="0">
+                <a:spcBef>
+                  <a:spcPts val="0"/>
+                </a:spcBef>
+                <a:spcAft>
+                  <a:spcPts val="0"/>
+                </a:spcAft>
+              </a:pPr>
+              <a:r>
+                <a:rPr sz="720" i="0" b="0">
+                  <a:solidFill>
+                    <a:srgbClr val="164BCE">
+                      <a:alpha val="100000"/>
+                    </a:srgbClr>
+                  </a:solidFill>
+                  <a:latin typeface="Arial"/>
+                  <a:cs typeface="Arial"/>
+                </a:rPr>
+                <a:t>purine ribonucleoside monophosphate biosynthetic</a:t>
+              </a:r>
+            </a:p>
+          </p:txBody>
+        </p:sp>
+        <p:sp>
+          <p:nvSpPr>
+            <p:cNvPr id="379" name="tx164"/>
+            <p:cNvSpPr/>
+            <p:nvPr/>
+          </p:nvSpPr>
+          <p:spPr>
+            <a:xfrm>
+              <a:off x="5730165" y="889408"/>
               <a:ext cx="319491" cy="65379"/>
             </a:xfrm>
             <a:prstGeom prst="rect">
@@ -16191,480 +16621,7 @@
         </p:sp>
         <p:sp>
           <p:nvSpPr>
-            <p:cNvPr id="370" name="tx155"/>
-            <p:cNvSpPr/>
-            <p:nvPr/>
-          </p:nvSpPr>
-          <p:spPr>
-            <a:xfrm>
-              <a:off x="4492616" y="1876421"/>
-              <a:ext cx="1557040" cy="65379"/>
-            </a:xfrm>
-            <a:prstGeom prst="rect">
-              <a:avLst/>
-            </a:prstGeom>
-            <a:noFill/>
-          </p:spPr>
-          <p:txBody>
-            <a:bodyPr lIns="0" rIns="0" tIns="0" bIns="0" anchorCtr="1" anchor="ctr" wrap="none"/>
-            <a:lstStyle/>
-            <a:p>
-              <a:pPr algn="l" marL="0" marR="0" indent="0">
-                <a:spcBef>
-                  <a:spcPts val="0"/>
-                </a:spcBef>
-                <a:spcAft>
-                  <a:spcPts val="0"/>
-                </a:spcAft>
-              </a:pPr>
-              <a:r>
-                <a:rPr sz="720" i="0" b="0">
-                  <a:solidFill>
-                    <a:srgbClr val="164BCE">
-                      <a:alpha val="100000"/>
-                    </a:srgbClr>
-                  </a:solidFill>
-                  <a:latin typeface="Arial"/>
-                  <a:cs typeface="Arial"/>
-                </a:rPr>
-                <a:t>monocarboxylic acid catabolic process</a:t>
-              </a:r>
-            </a:p>
-          </p:txBody>
-        </p:sp>
-        <p:sp>
-          <p:nvSpPr>
-            <p:cNvPr id="371" name="tx156"/>
-            <p:cNvSpPr/>
-            <p:nvPr/>
-          </p:nvSpPr>
-          <p:spPr>
-            <a:xfrm>
-              <a:off x="4832315" y="1761267"/>
-              <a:ext cx="1217340" cy="65379"/>
-            </a:xfrm>
-            <a:prstGeom prst="rect">
-              <a:avLst/>
-            </a:prstGeom>
-            <a:noFill/>
-          </p:spPr>
-          <p:txBody>
-            <a:bodyPr lIns="0" rIns="0" tIns="0" bIns="0" anchorCtr="1" anchor="ctr" wrap="none"/>
-            <a:lstStyle/>
-            <a:p>
-              <a:pPr algn="l" marL="0" marR="0" indent="0">
-                <a:spcBef>
-                  <a:spcPts val="0"/>
-                </a:spcBef>
-                <a:spcAft>
-                  <a:spcPts val="0"/>
-                </a:spcAft>
-              </a:pPr>
-              <a:r>
-                <a:rPr sz="720" i="0" b="0">
-                  <a:solidFill>
-                    <a:srgbClr val="159230">
-                      <a:alpha val="100000"/>
-                    </a:srgbClr>
-                  </a:solidFill>
-                  <a:latin typeface="Arial"/>
-                  <a:cs typeface="Arial"/>
-                </a:rPr>
-                <a:t>determination of adult lifespan</a:t>
-              </a:r>
-            </a:p>
-          </p:txBody>
-        </p:sp>
-        <p:sp>
-          <p:nvSpPr>
-            <p:cNvPr id="372" name="tx157"/>
-            <p:cNvSpPr/>
-            <p:nvPr/>
-          </p:nvSpPr>
-          <p:spPr>
-            <a:xfrm>
-              <a:off x="4822166" y="1646112"/>
-              <a:ext cx="1227490" cy="65379"/>
-            </a:xfrm>
-            <a:prstGeom prst="rect">
-              <a:avLst/>
-            </a:prstGeom>
-            <a:noFill/>
-          </p:spPr>
-          <p:txBody>
-            <a:bodyPr lIns="0" rIns="0" tIns="0" bIns="0" anchorCtr="1" anchor="ctr" wrap="none"/>
-            <a:lstStyle/>
-            <a:p>
-              <a:pPr algn="l" marL="0" marR="0" indent="0">
-                <a:spcBef>
-                  <a:spcPts val="0"/>
-                </a:spcBef>
-                <a:spcAft>
-                  <a:spcPts val="0"/>
-                </a:spcAft>
-              </a:pPr>
-              <a:r>
-                <a:rPr sz="720" i="0" b="0">
-                  <a:solidFill>
-                    <a:srgbClr val="164BCE">
-                      <a:alpha val="100000"/>
-                    </a:srgbClr>
-                  </a:solidFill>
-                  <a:latin typeface="Arial"/>
-                  <a:cs typeface="Arial"/>
-                </a:rPr>
-                <a:t>nucleobase metabolic process</a:t>
-              </a:r>
-            </a:p>
-          </p:txBody>
-        </p:sp>
-        <p:sp>
-          <p:nvSpPr>
-            <p:cNvPr id="373" name="tx158"/>
-            <p:cNvSpPr/>
-            <p:nvPr/>
-          </p:nvSpPr>
-          <p:spPr>
-            <a:xfrm>
-              <a:off x="4487312" y="1530957"/>
-              <a:ext cx="1562343" cy="65379"/>
-            </a:xfrm>
-            <a:prstGeom prst="rect">
-              <a:avLst/>
-            </a:prstGeom>
-            <a:noFill/>
-          </p:spPr>
-          <p:txBody>
-            <a:bodyPr lIns="0" rIns="0" tIns="0" bIns="0" anchorCtr="1" anchor="ctr" wrap="none"/>
-            <a:lstStyle/>
-            <a:p>
-              <a:pPr algn="l" marL="0" marR="0" indent="0">
-                <a:spcBef>
-                  <a:spcPts val="0"/>
-                </a:spcBef>
-                <a:spcAft>
-                  <a:spcPts val="0"/>
-                </a:spcAft>
-              </a:pPr>
-              <a:r>
-                <a:rPr sz="720" i="0" b="0">
-                  <a:solidFill>
-                    <a:srgbClr val="111111">
-                      <a:alpha val="100000"/>
-                    </a:srgbClr>
-                  </a:solidFill>
-                  <a:latin typeface="Arial"/>
-                  <a:cs typeface="Arial"/>
-                </a:rPr>
-                <a:t>organophosphate biosynthetic process</a:t>
-              </a:r>
-            </a:p>
-          </p:txBody>
-        </p:sp>
-        <p:sp>
-          <p:nvSpPr>
-            <p:cNvPr id="374" name="tx159"/>
-            <p:cNvSpPr/>
-            <p:nvPr/>
-          </p:nvSpPr>
-          <p:spPr>
-            <a:xfrm>
-              <a:off x="4918543" y="1415803"/>
-              <a:ext cx="1131112" cy="65379"/>
-            </a:xfrm>
-            <a:prstGeom prst="rect">
-              <a:avLst/>
-            </a:prstGeom>
-            <a:noFill/>
-          </p:spPr>
-          <p:txBody>
-            <a:bodyPr lIns="0" rIns="0" tIns="0" bIns="0" anchorCtr="1" anchor="ctr" wrap="none"/>
-            <a:lstStyle/>
-            <a:p>
-              <a:pPr algn="l" marL="0" marR="0" indent="0">
-                <a:spcBef>
-                  <a:spcPts val="0"/>
-                </a:spcBef>
-                <a:spcAft>
-                  <a:spcPts val="0"/>
-                </a:spcAft>
-              </a:pPr>
-              <a:r>
-                <a:rPr sz="720" i="0" b="0">
-                  <a:solidFill>
-                    <a:srgbClr val="164BCE">
-                      <a:alpha val="100000"/>
-                    </a:srgbClr>
-                  </a:solidFill>
-                  <a:latin typeface="Arial"/>
-                  <a:cs typeface="Arial"/>
-                </a:rPr>
-                <a:t>aldehyde metabolic process</a:t>
-              </a:r>
-            </a:p>
-          </p:txBody>
-        </p:sp>
-        <p:sp>
-          <p:nvSpPr>
-            <p:cNvPr id="375" name="tx160"/>
-            <p:cNvSpPr/>
-            <p:nvPr/>
-          </p:nvSpPr>
-          <p:spPr>
-            <a:xfrm>
-              <a:off x="4249203" y="1300648"/>
-              <a:ext cx="1800453" cy="65379"/>
-            </a:xfrm>
-            <a:prstGeom prst="rect">
-              <a:avLst/>
-            </a:prstGeom>
-            <a:noFill/>
-          </p:spPr>
-          <p:txBody>
-            <a:bodyPr lIns="0" rIns="0" tIns="0" bIns="0" anchorCtr="1" anchor="ctr" wrap="none"/>
-            <a:lstStyle/>
-            <a:p>
-              <a:pPr algn="l" marL="0" marR="0" indent="0">
-                <a:spcBef>
-                  <a:spcPts val="0"/>
-                </a:spcBef>
-                <a:spcAft>
-                  <a:spcPts val="0"/>
-                </a:spcAft>
-              </a:pPr>
-              <a:r>
-                <a:rPr sz="720" i="0" b="0">
-                  <a:solidFill>
-                    <a:srgbClr val="164BCE">
-                      <a:alpha val="100000"/>
-                    </a:srgbClr>
-                  </a:solidFill>
-                  <a:latin typeface="Arial"/>
-                  <a:cs typeface="Arial"/>
-                </a:rPr>
-                <a:t>carbohydrate derivative biosynthetic process</a:t>
-              </a:r>
-            </a:p>
-          </p:txBody>
-        </p:sp>
-        <p:sp>
-          <p:nvSpPr>
-            <p:cNvPr id="376" name="tx161"/>
-            <p:cNvSpPr/>
-            <p:nvPr/>
-          </p:nvSpPr>
-          <p:spPr>
-            <a:xfrm>
-              <a:off x="4796928" y="1185494"/>
-              <a:ext cx="1252728" cy="65379"/>
-            </a:xfrm>
-            <a:prstGeom prst="rect">
-              <a:avLst/>
-            </a:prstGeom>
-            <a:noFill/>
-          </p:spPr>
-          <p:txBody>
-            <a:bodyPr lIns="0" rIns="0" tIns="0" bIns="0" anchorCtr="1" anchor="ctr" wrap="none"/>
-            <a:lstStyle/>
-            <a:p>
-              <a:pPr algn="l" marL="0" marR="0" indent="0">
-                <a:spcBef>
-                  <a:spcPts val="0"/>
-                </a:spcBef>
-                <a:spcAft>
-                  <a:spcPts val="0"/>
-                </a:spcAft>
-              </a:pPr>
-              <a:r>
-                <a:rPr sz="720" i="0" b="0">
-                  <a:solidFill>
-                    <a:srgbClr val="164BCE">
-                      <a:alpha val="100000"/>
-                    </a:srgbClr>
-                  </a:solidFill>
-                  <a:latin typeface="Arial"/>
-                  <a:cs typeface="Arial"/>
-                </a:rPr>
-                <a:t>L-amino acid catabolic process</a:t>
-              </a:r>
-            </a:p>
-          </p:txBody>
-        </p:sp>
-        <p:sp>
-          <p:nvSpPr>
-            <p:cNvPr id="377" name="tx162"/>
-            <p:cNvSpPr/>
-            <p:nvPr/>
-          </p:nvSpPr>
-          <p:spPr>
-            <a:xfrm>
-              <a:off x="4619443" y="1070339"/>
-              <a:ext cx="1430213" cy="65379"/>
-            </a:xfrm>
-            <a:prstGeom prst="rect">
-              <a:avLst/>
-            </a:prstGeom>
-            <a:noFill/>
-          </p:spPr>
-          <p:txBody>
-            <a:bodyPr lIns="0" rIns="0" tIns="0" bIns="0" anchorCtr="1" anchor="ctr" wrap="none"/>
-            <a:lstStyle/>
-            <a:p>
-              <a:pPr algn="l" marL="0" marR="0" indent="0">
-                <a:spcBef>
-                  <a:spcPts val="0"/>
-                </a:spcBef>
-                <a:spcAft>
-                  <a:spcPts val="0"/>
-                </a:spcAft>
-              </a:pPr>
-              <a:r>
-                <a:rPr sz="720" i="0" b="0">
-                  <a:solidFill>
-                    <a:srgbClr val="164BCE">
-                      <a:alpha val="100000"/>
-                    </a:srgbClr>
-                  </a:solidFill>
-                  <a:latin typeface="Arial"/>
-                  <a:cs typeface="Arial"/>
-                </a:rPr>
-                <a:t>dicarboxylic acid metabolic process</a:t>
-              </a:r>
-            </a:p>
-          </p:txBody>
-        </p:sp>
-        <p:sp>
-          <p:nvSpPr>
-            <p:cNvPr id="378" name="tx163"/>
-            <p:cNvSpPr/>
-            <p:nvPr/>
-          </p:nvSpPr>
-          <p:spPr>
-            <a:xfrm>
-              <a:off x="4431900" y="955185"/>
-              <a:ext cx="1617756" cy="65379"/>
-            </a:xfrm>
-            <a:prstGeom prst="rect">
-              <a:avLst/>
-            </a:prstGeom>
-            <a:noFill/>
-          </p:spPr>
-          <p:txBody>
-            <a:bodyPr lIns="0" rIns="0" tIns="0" bIns="0" anchorCtr="1" anchor="ctr" wrap="none"/>
-            <a:lstStyle/>
-            <a:p>
-              <a:pPr algn="l" marL="0" marR="0" indent="0">
-                <a:spcBef>
-                  <a:spcPts val="0"/>
-                </a:spcBef>
-                <a:spcAft>
-                  <a:spcPts val="0"/>
-                </a:spcAft>
-              </a:pPr>
-              <a:r>
-                <a:rPr sz="720" i="0" b="0">
-                  <a:solidFill>
-                    <a:srgbClr val="164BCE">
-                      <a:alpha val="100000"/>
-                    </a:srgbClr>
-                  </a:solidFill>
-                  <a:latin typeface="Arial"/>
-                  <a:cs typeface="Arial"/>
-                </a:rPr>
-                <a:t>water-soluble vitamin metabolic process</a:t>
-              </a:r>
-            </a:p>
-          </p:txBody>
-        </p:sp>
-        <p:sp>
-          <p:nvSpPr>
-            <p:cNvPr id="379" name="tx164"/>
-            <p:cNvSpPr/>
-            <p:nvPr/>
-          </p:nvSpPr>
-          <p:spPr>
-            <a:xfrm>
-              <a:off x="3995182" y="790652"/>
-              <a:ext cx="2054473" cy="65379"/>
-            </a:xfrm>
-            <a:prstGeom prst="rect">
-              <a:avLst/>
-            </a:prstGeom>
-            <a:noFill/>
-          </p:spPr>
-          <p:txBody>
-            <a:bodyPr lIns="0" rIns="0" tIns="0" bIns="0" anchorCtr="1" anchor="ctr" wrap="none"/>
-            <a:lstStyle/>
-            <a:p>
-              <a:pPr algn="l" marL="0" marR="0" indent="0">
-                <a:spcBef>
-                  <a:spcPts val="0"/>
-                </a:spcBef>
-                <a:spcAft>
-                  <a:spcPts val="0"/>
-                </a:spcAft>
-              </a:pPr>
-              <a:r>
-                <a:rPr sz="720" i="0" b="0">
-                  <a:solidFill>
-                    <a:srgbClr val="164BCE">
-                      <a:alpha val="100000"/>
-                    </a:srgbClr>
-                  </a:solidFill>
-                  <a:latin typeface="Arial"/>
-                  <a:cs typeface="Arial"/>
-                </a:rPr>
-                <a:t>purine ribonucleoside monophosphate biosynthetic</a:t>
-              </a:r>
-            </a:p>
-          </p:txBody>
-        </p:sp>
-        <p:sp>
-          <p:nvSpPr>
             <p:cNvPr id="380" name="tx165"/>
-            <p:cNvSpPr/>
-            <p:nvPr/>
-          </p:nvSpPr>
-          <p:spPr>
-            <a:xfrm>
-              <a:off x="5730165" y="889408"/>
-              <a:ext cx="319491" cy="65379"/>
-            </a:xfrm>
-            <a:prstGeom prst="rect">
-              <a:avLst/>
-            </a:prstGeom>
-            <a:noFill/>
-          </p:spPr>
-          <p:txBody>
-            <a:bodyPr lIns="0" rIns="0" tIns="0" bIns="0" anchorCtr="1" anchor="ctr" wrap="none"/>
-            <a:lstStyle/>
-            <a:p>
-              <a:pPr algn="l" marL="0" marR="0" indent="0">
-                <a:spcBef>
-                  <a:spcPts val="0"/>
-                </a:spcBef>
-                <a:spcAft>
-                  <a:spcPts val="0"/>
-                </a:spcAft>
-              </a:pPr>
-              <a:r>
-                <a:rPr sz="720" i="0" b="0">
-                  <a:solidFill>
-                    <a:srgbClr val="164BCE">
-                      <a:alpha val="100000"/>
-                    </a:srgbClr>
-                  </a:solidFill>
-                  <a:latin typeface="Arial"/>
-                  <a:cs typeface="Arial"/>
-                </a:rPr>
-                <a:t>process</a:t>
-              </a:r>
-            </a:p>
-          </p:txBody>
-        </p:sp>
-        <p:sp>
-          <p:nvSpPr>
-            <p:cNvPr id="381" name="tx166"/>
             <p:cNvSpPr/>
             <p:nvPr/>
           </p:nvSpPr>
@@ -16707,7 +16664,7 @@
         </p:sp>
         <p:sp>
           <p:nvSpPr>
-            <p:cNvPr id="382" name="tx167"/>
+            <p:cNvPr id="381" name="tx166"/>
             <p:cNvSpPr/>
             <p:nvPr/>
           </p:nvSpPr>
@@ -16750,7 +16707,7 @@
         </p:sp>
         <p:sp>
           <p:nvSpPr>
-            <p:cNvPr id="383" name="tx168"/>
+            <p:cNvPr id="382" name="tx167"/>
             <p:cNvSpPr/>
             <p:nvPr/>
           </p:nvSpPr>
@@ -16793,7 +16750,7 @@
         </p:sp>
         <p:sp>
           <p:nvSpPr>
-            <p:cNvPr id="384" name="tx169"/>
+            <p:cNvPr id="383" name="tx168"/>
             <p:cNvSpPr/>
             <p:nvPr/>
           </p:nvSpPr>
@@ -16836,7 +16793,7 @@
         </p:sp>
         <p:sp>
           <p:nvSpPr>
-            <p:cNvPr id="385" name="tx170"/>
+            <p:cNvPr id="384" name="tx169"/>
             <p:cNvSpPr/>
             <p:nvPr/>
           </p:nvSpPr>
@@ -16879,7 +16836,7 @@
         </p:sp>
         <p:sp>
           <p:nvSpPr>
-            <p:cNvPr id="386" name="tx171"/>
+            <p:cNvPr id="385" name="tx170"/>
             <p:cNvSpPr/>
             <p:nvPr/>
           </p:nvSpPr>
@@ -16922,7 +16879,7 @@
         </p:sp>
         <p:sp>
           <p:nvSpPr>
-            <p:cNvPr id="387" name="tx172"/>
+            <p:cNvPr id="386" name="tx171"/>
             <p:cNvSpPr/>
             <p:nvPr/>
           </p:nvSpPr>
@@ -16965,7 +16922,7 @@
         </p:sp>
         <p:sp>
           <p:nvSpPr>
-            <p:cNvPr id="388" name="tx173"/>
+            <p:cNvPr id="387" name="tx172"/>
             <p:cNvSpPr/>
             <p:nvPr/>
           </p:nvSpPr>
@@ -17008,7 +16965,7 @@
         </p:sp>
         <p:sp>
           <p:nvSpPr>
-            <p:cNvPr id="389" name="tx174"/>
+            <p:cNvPr id="388" name="tx173"/>
             <p:cNvSpPr/>
             <p:nvPr/>
           </p:nvSpPr>
@@ -17051,7 +17008,7 @@
         </p:sp>
         <p:sp>
           <p:nvSpPr>
-            <p:cNvPr id="390" name="tx175"/>
+            <p:cNvPr id="389" name="tx174"/>
             <p:cNvSpPr/>
             <p:nvPr/>
           </p:nvSpPr>
@@ -17094,7 +17051,7 @@
         </p:sp>
         <p:sp>
           <p:nvSpPr>
-            <p:cNvPr id="391" name="tx176"/>
+            <p:cNvPr id="390" name="tx175"/>
             <p:cNvSpPr/>
             <p:nvPr/>
           </p:nvSpPr>
@@ -17137,7 +17094,7 @@
         </p:sp>
         <p:sp>
           <p:nvSpPr>
-            <p:cNvPr id="392" name="tx177"/>
+            <p:cNvPr id="391" name="tx176"/>
             <p:cNvSpPr/>
             <p:nvPr/>
           </p:nvSpPr>
@@ -17180,7 +17137,7 @@
         </p:sp>
         <p:sp>
           <p:nvSpPr>
-            <p:cNvPr id="393" name="tx178"/>
+            <p:cNvPr id="392" name="tx177"/>
             <p:cNvSpPr/>
             <p:nvPr/>
           </p:nvSpPr>
@@ -17223,7 +17180,7 @@
         </p:sp>
         <p:sp>
           <p:nvSpPr>
-            <p:cNvPr id="394" name="tx179"/>
+            <p:cNvPr id="393" name="tx178"/>
             <p:cNvSpPr/>
             <p:nvPr/>
           </p:nvSpPr>
@@ -17266,7 +17223,7 @@
         </p:sp>
         <p:sp>
           <p:nvSpPr>
-            <p:cNvPr id="395" name="tx180"/>
+            <p:cNvPr id="394" name="tx179"/>
             <p:cNvSpPr/>
             <p:nvPr/>
           </p:nvSpPr>
@@ -17309,7 +17266,7 @@
         </p:sp>
         <p:sp>
           <p:nvSpPr>
-            <p:cNvPr id="396" name="tx181"/>
+            <p:cNvPr id="395" name="tx180"/>
             <p:cNvSpPr/>
             <p:nvPr/>
           </p:nvSpPr>
@@ -17352,7 +17309,7 @@
         </p:sp>
         <p:sp>
           <p:nvSpPr>
-            <p:cNvPr id="397" name="tx182"/>
+            <p:cNvPr id="396" name="tx181"/>
             <p:cNvSpPr/>
             <p:nvPr/>
           </p:nvSpPr>
@@ -17395,7 +17352,7 @@
         </p:sp>
         <p:sp>
           <p:nvSpPr>
-            <p:cNvPr id="398" name="tx183"/>
+            <p:cNvPr id="397" name="tx182"/>
             <p:cNvSpPr/>
             <p:nvPr/>
           </p:nvSpPr>
@@ -17438,7 +17395,7 @@
         </p:sp>
         <p:sp>
           <p:nvSpPr>
-            <p:cNvPr id="399" name="tx184"/>
+            <p:cNvPr id="398" name="tx183"/>
             <p:cNvSpPr/>
             <p:nvPr/>
           </p:nvSpPr>
@@ -17481,7 +17438,7 @@
         </p:sp>
         <p:sp>
           <p:nvSpPr>
-            <p:cNvPr id="400" name="tx185"/>
+            <p:cNvPr id="399" name="tx184"/>
             <p:cNvSpPr/>
             <p:nvPr/>
           </p:nvSpPr>
@@ -17524,7 +17481,7 @@
         </p:sp>
         <p:sp>
           <p:nvSpPr>
-            <p:cNvPr id="401" name="tx186"/>
+            <p:cNvPr id="400" name="tx185"/>
             <p:cNvSpPr/>
             <p:nvPr/>
           </p:nvSpPr>
@@ -17567,7 +17524,7 @@
         </p:sp>
         <p:sp>
           <p:nvSpPr>
-            <p:cNvPr id="402" name="tx187"/>
+            <p:cNvPr id="401" name="tx186"/>
             <p:cNvSpPr/>
             <p:nvPr/>
           </p:nvSpPr>
@@ -17610,7 +17567,7 @@
         </p:sp>
         <p:sp>
           <p:nvSpPr>
-            <p:cNvPr id="403" name="tx188"/>
+            <p:cNvPr id="402" name="tx187"/>
             <p:cNvSpPr/>
             <p:nvPr/>
           </p:nvSpPr>
@@ -17653,7 +17610,7 @@
         </p:sp>
         <p:sp>
           <p:nvSpPr>
-            <p:cNvPr id="404" name="tx189"/>
+            <p:cNvPr id="403" name="tx188"/>
             <p:cNvSpPr/>
             <p:nvPr/>
           </p:nvSpPr>
@@ -17696,7 +17653,7 @@
         </p:sp>
         <p:sp>
           <p:nvSpPr>
-            <p:cNvPr id="405" name="pt190"/>
+            <p:cNvPr id="404" name="pt189"/>
             <p:cNvSpPr/>
             <p:nvPr/>
           </p:nvSpPr>
@@ -17731,7 +17688,7 @@
         </p:sp>
         <p:sp>
           <p:nvSpPr>
-            <p:cNvPr id="406" name="pt191"/>
+            <p:cNvPr id="405" name="pt190"/>
             <p:cNvSpPr/>
             <p:nvPr/>
           </p:nvSpPr>
@@ -17766,7 +17723,7 @@
         </p:sp>
         <p:sp>
           <p:nvSpPr>
-            <p:cNvPr id="407" name="pt192"/>
+            <p:cNvPr id="406" name="pt191"/>
             <p:cNvSpPr/>
             <p:nvPr/>
           </p:nvSpPr>
@@ -17801,7 +17758,7 @@
         </p:sp>
         <p:sp>
           <p:nvSpPr>
-            <p:cNvPr id="408" name="pt193"/>
+            <p:cNvPr id="407" name="pt192"/>
             <p:cNvSpPr/>
             <p:nvPr/>
           </p:nvSpPr>
@@ -17836,7 +17793,7 @@
         </p:sp>
         <p:sp>
           <p:nvSpPr>
-            <p:cNvPr id="409" name="tx194"/>
+            <p:cNvPr id="408" name="tx193"/>
             <p:cNvSpPr/>
             <p:nvPr/>
           </p:nvSpPr>
@@ -17879,7 +17836,7 @@
         </p:sp>
         <p:sp>
           <p:nvSpPr>
-            <p:cNvPr id="410" name="tx195"/>
+            <p:cNvPr id="409" name="tx194"/>
             <p:cNvSpPr/>
             <p:nvPr/>
           </p:nvSpPr>
@@ -17922,7 +17879,7 @@
         </p:sp>
         <p:sp>
           <p:nvSpPr>
-            <p:cNvPr id="411" name="tx196"/>
+            <p:cNvPr id="410" name="tx195"/>
             <p:cNvSpPr/>
             <p:nvPr/>
           </p:nvSpPr>
@@ -17965,7 +17922,7 @@
         </p:sp>
         <p:sp>
           <p:nvSpPr>
-            <p:cNvPr id="412" name="tx197"/>
+            <p:cNvPr id="411" name="tx196"/>
             <p:cNvSpPr/>
             <p:nvPr/>
           </p:nvSpPr>
@@ -18008,7 +17965,7 @@
         </p:sp>
         <p:sp>
           <p:nvSpPr>
-            <p:cNvPr id="413" name="tx198"/>
+            <p:cNvPr id="412" name="tx197"/>
             <p:cNvSpPr/>
             <p:nvPr/>
           </p:nvSpPr>
@@ -18051,7 +18008,7 @@
         </p:sp>
         <p:sp>
           <p:nvSpPr>
-            <p:cNvPr id="414" name="pt199"/>
+            <p:cNvPr id="413" name="pt198"/>
             <p:cNvSpPr/>
             <p:nvPr/>
           </p:nvSpPr>
@@ -18086,7 +18043,7 @@
         </p:sp>
         <p:sp>
           <p:nvSpPr>
-            <p:cNvPr id="415" name="pt200"/>
+            <p:cNvPr id="414" name="pt199"/>
             <p:cNvSpPr/>
             <p:nvPr/>
           </p:nvSpPr>
@@ -18121,7 +18078,7 @@
         </p:sp>
         <p:sp>
           <p:nvSpPr>
-            <p:cNvPr id="416" name="pt201"/>
+            <p:cNvPr id="415" name="pt200"/>
             <p:cNvSpPr/>
             <p:nvPr/>
           </p:nvSpPr>
@@ -18156,7 +18113,7 @@
         </p:sp>
         <p:sp>
           <p:nvSpPr>
-            <p:cNvPr id="417" name="pt202"/>
+            <p:cNvPr id="416" name="pt201"/>
             <p:cNvSpPr/>
             <p:nvPr/>
           </p:nvSpPr>
@@ -18191,7 +18148,7 @@
         </p:sp>
         <p:sp>
           <p:nvSpPr>
-            <p:cNvPr id="418" name="tx203"/>
+            <p:cNvPr id="417" name="tx202"/>
             <p:cNvSpPr/>
             <p:nvPr/>
           </p:nvSpPr>
@@ -18234,7 +18191,7 @@
         </p:sp>
         <p:sp>
           <p:nvSpPr>
-            <p:cNvPr id="419" name="tx204"/>
+            <p:cNvPr id="418" name="tx203"/>
             <p:cNvSpPr/>
             <p:nvPr/>
           </p:nvSpPr>
@@ -18277,7 +18234,7 @@
         </p:sp>
         <p:sp>
           <p:nvSpPr>
-            <p:cNvPr id="420" name="tx205"/>
+            <p:cNvPr id="419" name="tx204"/>
             <p:cNvSpPr/>
             <p:nvPr/>
           </p:nvSpPr>
@@ -18320,7 +18277,7 @@
         </p:sp>
         <p:sp>
           <p:nvSpPr>
-            <p:cNvPr id="421" name="tx206"/>
+            <p:cNvPr id="420" name="tx205"/>
             <p:cNvSpPr/>
             <p:nvPr/>
           </p:nvSpPr>
@@ -18364,7 +18321,7 @@
       </p:grpSp>
       <p:sp>
         <p:nvSpPr>
-          <p:cNvPr id="422" name=""/>
+          <p:cNvPr id="421" name=""/>
           <p:cNvSpPr>
             <a:spLocks noGrp="1"/>
           </p:cNvSpPr>
@@ -18413,7 +18370,7 @@
       </p:sp>
       <p:sp>
         <p:nvSpPr>
-          <p:cNvPr id="423" name=""/>
+          <p:cNvPr id="422" name=""/>
           <p:cNvSpPr>
             <a:spLocks noGrp="1"/>
           </p:cNvSpPr>

</xml_diff>